<commit_message>
docs: maj des docs de présentation
</commit_message>
<xml_diff>
--- a/docs/presentations/CDSD_bloc3_uber_GV.pptx
+++ b/docs/presentations/CDSD_bloc3_uber_GV.pptx
@@ -24,23 +24,26 @@
     <p:sldId id="269" r:id="rId19"/>
     <p:sldId id="270" r:id="rId20"/>
     <p:sldId id="271" r:id="rId21"/>
+    <p:sldId id="272" r:id="rId22"/>
+    <p:sldId id="273" r:id="rId23"/>
+    <p:sldId id="274" r:id="rId24"/>
   </p:sldIdLst>
   <p:sldSz cy="5143500" cx="9144000"/>
   <p:notesSz cx="6858000" cy="9144000"/>
   <p:embeddedFontLst>
     <p:embeddedFont>
       <p:font typeface="Roboto"/>
-      <p:regular r:id="rId22"/>
-      <p:bold r:id="rId23"/>
-      <p:italic r:id="rId24"/>
-      <p:boldItalic r:id="rId25"/>
+      <p:regular r:id="rId25"/>
+      <p:bold r:id="rId26"/>
+      <p:italic r:id="rId27"/>
+      <p:boldItalic r:id="rId28"/>
     </p:embeddedFont>
     <p:embeddedFont>
       <p:font typeface="Roboto Light"/>
-      <p:regular r:id="rId26"/>
-      <p:bold r:id="rId27"/>
-      <p:italic r:id="rId28"/>
-      <p:boldItalic r:id="rId29"/>
+      <p:regular r:id="rId29"/>
+      <p:bold r:id="rId30"/>
+      <p:italic r:id="rId31"/>
+      <p:boldItalic r:id="rId32"/>
     </p:embeddedFont>
   </p:embeddedFontLst>
   <p:defaultTextStyle>
@@ -845,7 +848,7 @@
       </p:grpSpPr>
       <p:sp>
         <p:nvSpPr>
-          <p:cNvPr id="140" name="Google Shape;140;g3ee42bc4f86_0_16:notes"/>
+          <p:cNvPr id="140" name="Google Shape;140;g3f56af012ea_0_0:notes"/>
           <p:cNvSpPr/>
           <p:nvPr>
             <p:ph idx="2" type="sldImg"/>
@@ -880,7 +883,7 @@
       </p:sp>
       <p:sp>
         <p:nvSpPr>
-          <p:cNvPr id="141" name="Google Shape;141;g3ee42bc4f86_0_16:notes"/>
+          <p:cNvPr id="141" name="Google Shape;141;g3f56af012ea_0_0:notes"/>
           <p:cNvSpPr txBox="1"/>
           <p:nvPr>
             <p:ph idx="1" type="body"/>
@@ -930,7 +933,7 @@
   <p:cSld>
     <p:spTree>
       <p:nvGrpSpPr>
-        <p:cNvPr id="149" name="Shape 149"/>
+        <p:cNvPr id="150" name="Shape 150"/>
         <p:cNvGrpSpPr/>
         <p:nvPr/>
       </p:nvGrpSpPr>
@@ -944,7 +947,7 @@
       </p:grpSpPr>
       <p:sp>
         <p:nvSpPr>
-          <p:cNvPr id="150" name="Google Shape;150;g3ee42bc4f86_0_71:notes"/>
+          <p:cNvPr id="151" name="Google Shape;151;g3ee42bc4f86_0_16:notes"/>
           <p:cNvSpPr/>
           <p:nvPr>
             <p:ph idx="2" type="sldImg"/>
@@ -979,7 +982,7 @@
       </p:sp>
       <p:sp>
         <p:nvSpPr>
-          <p:cNvPr id="151" name="Google Shape;151;g3ee42bc4f86_0_71:notes"/>
+          <p:cNvPr id="152" name="Google Shape;152;g3ee42bc4f86_0_16:notes"/>
           <p:cNvSpPr txBox="1"/>
           <p:nvPr>
             <p:ph idx="1" type="body"/>
@@ -1029,7 +1032,7 @@
   <p:cSld>
     <p:spTree>
       <p:nvGrpSpPr>
-        <p:cNvPr id="159" name="Shape 159"/>
+        <p:cNvPr id="160" name="Shape 160"/>
         <p:cNvGrpSpPr/>
         <p:nvPr/>
       </p:nvGrpSpPr>
@@ -1043,7 +1046,7 @@
       </p:grpSpPr>
       <p:sp>
         <p:nvSpPr>
-          <p:cNvPr id="160" name="Google Shape;160;g3ee42bc4f86_0_63:notes"/>
+          <p:cNvPr id="161" name="Google Shape;161;g3ee42bc4f86_0_71:notes"/>
           <p:cNvSpPr/>
           <p:nvPr>
             <p:ph idx="2" type="sldImg"/>
@@ -1078,7 +1081,7 @@
       </p:sp>
       <p:sp>
         <p:nvSpPr>
-          <p:cNvPr id="161" name="Google Shape;161;g3ee42bc4f86_0_63:notes"/>
+          <p:cNvPr id="162" name="Google Shape;162;g3ee42bc4f86_0_71:notes"/>
           <p:cNvSpPr txBox="1"/>
           <p:nvPr>
             <p:ph idx="1" type="body"/>
@@ -1128,7 +1131,7 @@
   <p:cSld>
     <p:spTree>
       <p:nvGrpSpPr>
-        <p:cNvPr id="169" name="Shape 169"/>
+        <p:cNvPr id="170" name="Shape 170"/>
         <p:cNvGrpSpPr/>
         <p:nvPr/>
       </p:nvGrpSpPr>
@@ -1142,7 +1145,7 @@
       </p:grpSpPr>
       <p:sp>
         <p:nvSpPr>
-          <p:cNvPr id="170" name="Google Shape;170;g3ee42bc4f86_0_54:notes"/>
+          <p:cNvPr id="171" name="Google Shape;171;g3ee42bc4f86_0_63:notes"/>
           <p:cNvSpPr/>
           <p:nvPr>
             <p:ph idx="2" type="sldImg"/>
@@ -1177,7 +1180,7 @@
       </p:sp>
       <p:sp>
         <p:nvSpPr>
-          <p:cNvPr id="171" name="Google Shape;171;g3ee42bc4f86_0_54:notes"/>
+          <p:cNvPr id="172" name="Google Shape;172;g3ee42bc4f86_0_63:notes"/>
           <p:cNvSpPr txBox="1"/>
           <p:nvPr>
             <p:ph idx="1" type="body"/>
@@ -1227,7 +1230,7 @@
   <p:cSld>
     <p:spTree>
       <p:nvGrpSpPr>
-        <p:cNvPr id="179" name="Shape 179"/>
+        <p:cNvPr id="180" name="Shape 180"/>
         <p:cNvGrpSpPr/>
         <p:nvPr/>
       </p:nvGrpSpPr>
@@ -1241,7 +1244,7 @@
       </p:grpSpPr>
       <p:sp>
         <p:nvSpPr>
-          <p:cNvPr id="180" name="Google Shape;180;g3ef6ef7ef33_0_12:notes"/>
+          <p:cNvPr id="181" name="Google Shape;181;g3ee42bc4f86_0_54:notes"/>
           <p:cNvSpPr/>
           <p:nvPr>
             <p:ph idx="2" type="sldImg"/>
@@ -1276,7 +1279,7 @@
       </p:sp>
       <p:sp>
         <p:nvSpPr>
-          <p:cNvPr id="181" name="Google Shape;181;g3ef6ef7ef33_0_12:notes"/>
+          <p:cNvPr id="182" name="Google Shape;182;g3ee42bc4f86_0_54:notes"/>
           <p:cNvSpPr txBox="1"/>
           <p:nvPr>
             <p:ph idx="1" type="body"/>
@@ -1326,7 +1329,7 @@
   <p:cSld>
     <p:spTree>
       <p:nvGrpSpPr>
-        <p:cNvPr id="189" name="Shape 189"/>
+        <p:cNvPr id="190" name="Shape 190"/>
         <p:cNvGrpSpPr/>
         <p:nvPr/>
       </p:nvGrpSpPr>
@@ -1340,7 +1343,7 @@
       </p:grpSpPr>
       <p:sp>
         <p:nvSpPr>
-          <p:cNvPr id="190" name="Google Shape;190;g3ef6ef7ef33_0_0:notes"/>
+          <p:cNvPr id="191" name="Google Shape;191;g3ef6ef7ef33_0_12:notes"/>
           <p:cNvSpPr/>
           <p:nvPr>
             <p:ph idx="2" type="sldImg"/>
@@ -1375,7 +1378,7 @@
       </p:sp>
       <p:sp>
         <p:nvSpPr>
-          <p:cNvPr id="191" name="Google Shape;191;g3ef6ef7ef33_0_0:notes"/>
+          <p:cNvPr id="192" name="Google Shape;192;g3ef6ef7ef33_0_12:notes"/>
           <p:cNvSpPr txBox="1"/>
           <p:nvPr>
             <p:ph idx="1" type="body"/>
@@ -1425,7 +1428,7 @@
   <p:cSld>
     <p:spTree>
       <p:nvGrpSpPr>
-        <p:cNvPr id="198" name="Shape 198"/>
+        <p:cNvPr id="200" name="Shape 200"/>
         <p:cNvGrpSpPr/>
         <p:nvPr/>
       </p:nvGrpSpPr>
@@ -1439,7 +1442,7 @@
       </p:grpSpPr>
       <p:sp>
         <p:nvSpPr>
-          <p:cNvPr id="199" name="Google Shape;199;g3edf06be40a_0_383:notes"/>
+          <p:cNvPr id="201" name="Google Shape;201;g3ef6ef7ef33_0_0:notes"/>
           <p:cNvSpPr/>
           <p:nvPr>
             <p:ph idx="2" type="sldImg"/>
@@ -1474,7 +1477,304 @@
       </p:sp>
       <p:sp>
         <p:nvSpPr>
-          <p:cNvPr id="200" name="Google Shape;200;g3edf06be40a_0_383:notes"/>
+          <p:cNvPr id="202" name="Google Shape;202;g3ef6ef7ef33_0_0:notes"/>
+          <p:cNvSpPr txBox="1"/>
+          <p:nvPr>
+            <p:ph idx="1" type="body"/>
+          </p:nvPr>
+        </p:nvSpPr>
+        <p:spPr>
+          <a:xfrm>
+            <a:off x="685800" y="4343400"/>
+            <a:ext cx="5486400" cy="4114800"/>
+          </a:xfrm>
+          <a:prstGeom prst="rect">
+            <a:avLst/>
+          </a:prstGeom>
+        </p:spPr>
+        <p:txBody>
+          <a:bodyPr anchorCtr="0" anchor="t" bIns="91425" lIns="91425" spcFirstLastPara="1" rIns="91425" wrap="square" tIns="91425">
+            <a:noAutofit/>
+          </a:bodyPr>
+          <a:lstStyle/>
+          <a:p>
+            <a:pPr indent="0" lvl="0" marL="0" rtl="0" algn="l">
+              <a:spcBef>
+                <a:spcPts val="0"/>
+              </a:spcBef>
+              <a:spcAft>
+                <a:spcPts val="0"/>
+              </a:spcAft>
+              <a:buNone/>
+            </a:pPr>
+            <a:r>
+              <a:t/>
+            </a:r>
+            <a:endParaRPr/>
+          </a:p>
+        </p:txBody>
+      </p:sp>
+    </p:spTree>
+  </p:cSld>
+  <p:clrMapOvr>
+    <a:masterClrMapping/>
+  </p:clrMapOvr>
+</p:notes>
+</file>
+
+<file path=ppt/notesSlides/notesSlide17.xml><?xml version="1.0" encoding="utf-8"?>
+<p:notes xmlns:a="http://schemas.openxmlformats.org/drawingml/2006/main" xmlns:r="http://schemas.openxmlformats.org/officeDocument/2006/relationships" xmlns:mc="http://schemas.openxmlformats.org/markup-compatibility/2006" xmlns:mv="urn:schemas-microsoft-com:mac:vml" xmlns:p="http://schemas.openxmlformats.org/presentationml/2006/main" xmlns:c="http://schemas.openxmlformats.org/drawingml/2006/chart" xmlns:dgm="http://schemas.openxmlformats.org/drawingml/2006/diagram" xmlns:o="urn:schemas-microsoft-com:office:office" xmlns:v="urn:schemas-microsoft-com:vml" xmlns:pvml="urn:schemas-microsoft-com:office:powerpoint" xmlns:com="http://schemas.openxmlformats.org/drawingml/2006/compatibility" xmlns:p14="http://schemas.microsoft.com/office/powerpoint/2010/main" xmlns:p15="http://schemas.microsoft.com/office/powerpoint/2012/main" xmlns:ahyp="http://schemas.microsoft.com/office/drawing/2018/hyperlinkcolor" showMasterPhAnim="0" showMasterSp="0">
+  <p:cSld>
+    <p:spTree>
+      <p:nvGrpSpPr>
+        <p:cNvPr id="209" name="Shape 209"/>
+        <p:cNvGrpSpPr/>
+        <p:nvPr/>
+      </p:nvGrpSpPr>
+      <p:grpSpPr>
+        <a:xfrm>
+          <a:off x="0" y="0"/>
+          <a:ext cx="0" cy="0"/>
+          <a:chOff x="0" y="0"/>
+          <a:chExt cx="0" cy="0"/>
+        </a:xfrm>
+      </p:grpSpPr>
+      <p:sp>
+        <p:nvSpPr>
+          <p:cNvPr id="210" name="Google Shape;210;g3f56af012ea_0_14:notes"/>
+          <p:cNvSpPr/>
+          <p:nvPr>
+            <p:ph idx="2" type="sldImg"/>
+          </p:nvPr>
+        </p:nvSpPr>
+        <p:spPr>
+          <a:xfrm>
+            <a:off x="381300" y="685800"/>
+            <a:ext cx="6096000" cy="3429000"/>
+          </a:xfrm>
+          <a:custGeom>
+            <a:rect b="b" l="l" r="r" t="t"/>
+            <a:pathLst>
+              <a:path extrusionOk="0" h="120000" w="120000">
+                <a:moveTo>
+                  <a:pt x="0" y="0"/>
+                </a:moveTo>
+                <a:lnTo>
+                  <a:pt x="120000" y="0"/>
+                </a:lnTo>
+                <a:lnTo>
+                  <a:pt x="120000" y="120000"/>
+                </a:lnTo>
+                <a:lnTo>
+                  <a:pt x="0" y="120000"/>
+                </a:lnTo>
+                <a:close/>
+              </a:path>
+            </a:pathLst>
+          </a:custGeom>
+        </p:spPr>
+      </p:sp>
+      <p:sp>
+        <p:nvSpPr>
+          <p:cNvPr id="211" name="Google Shape;211;g3f56af012ea_0_14:notes"/>
+          <p:cNvSpPr txBox="1"/>
+          <p:nvPr>
+            <p:ph idx="1" type="body"/>
+          </p:nvPr>
+        </p:nvSpPr>
+        <p:spPr>
+          <a:xfrm>
+            <a:off x="685800" y="4343400"/>
+            <a:ext cx="5486400" cy="4114800"/>
+          </a:xfrm>
+          <a:prstGeom prst="rect">
+            <a:avLst/>
+          </a:prstGeom>
+        </p:spPr>
+        <p:txBody>
+          <a:bodyPr anchorCtr="0" anchor="t" bIns="91425" lIns="91425" spcFirstLastPara="1" rIns="91425" wrap="square" tIns="91425">
+            <a:noAutofit/>
+          </a:bodyPr>
+          <a:lstStyle/>
+          <a:p>
+            <a:pPr indent="0" lvl="0" marL="0" rtl="0" algn="l">
+              <a:spcBef>
+                <a:spcPts val="0"/>
+              </a:spcBef>
+              <a:spcAft>
+                <a:spcPts val="0"/>
+              </a:spcAft>
+              <a:buNone/>
+            </a:pPr>
+            <a:r>
+              <a:t/>
+            </a:r>
+            <a:endParaRPr/>
+          </a:p>
+        </p:txBody>
+      </p:sp>
+    </p:spTree>
+  </p:cSld>
+  <p:clrMapOvr>
+    <a:masterClrMapping/>
+  </p:clrMapOvr>
+</p:notes>
+</file>
+
+<file path=ppt/notesSlides/notesSlide18.xml><?xml version="1.0" encoding="utf-8"?>
+<p:notes xmlns:a="http://schemas.openxmlformats.org/drawingml/2006/main" xmlns:r="http://schemas.openxmlformats.org/officeDocument/2006/relationships" xmlns:mc="http://schemas.openxmlformats.org/markup-compatibility/2006" xmlns:mv="urn:schemas-microsoft-com:mac:vml" xmlns:p="http://schemas.openxmlformats.org/presentationml/2006/main" xmlns:c="http://schemas.openxmlformats.org/drawingml/2006/chart" xmlns:dgm="http://schemas.openxmlformats.org/drawingml/2006/diagram" xmlns:o="urn:schemas-microsoft-com:office:office" xmlns:v="urn:schemas-microsoft-com:vml" xmlns:pvml="urn:schemas-microsoft-com:office:powerpoint" xmlns:com="http://schemas.openxmlformats.org/drawingml/2006/compatibility" xmlns:p14="http://schemas.microsoft.com/office/powerpoint/2010/main" xmlns:p15="http://schemas.microsoft.com/office/powerpoint/2012/main" xmlns:ahyp="http://schemas.microsoft.com/office/drawing/2018/hyperlinkcolor" showMasterPhAnim="0" showMasterSp="0">
+  <p:cSld>
+    <p:spTree>
+      <p:nvGrpSpPr>
+        <p:cNvPr id="217" name="Shape 217"/>
+        <p:cNvGrpSpPr/>
+        <p:nvPr/>
+      </p:nvGrpSpPr>
+      <p:grpSpPr>
+        <a:xfrm>
+          <a:off x="0" y="0"/>
+          <a:ext cx="0" cy="0"/>
+          <a:chOff x="0" y="0"/>
+          <a:chExt cx="0" cy="0"/>
+        </a:xfrm>
+      </p:grpSpPr>
+      <p:sp>
+        <p:nvSpPr>
+          <p:cNvPr id="218" name="Google Shape;218;g3f56af012ea_0_21:notes"/>
+          <p:cNvSpPr/>
+          <p:nvPr>
+            <p:ph idx="2" type="sldImg"/>
+          </p:nvPr>
+        </p:nvSpPr>
+        <p:spPr>
+          <a:xfrm>
+            <a:off x="381300" y="685800"/>
+            <a:ext cx="6096000" cy="3429000"/>
+          </a:xfrm>
+          <a:custGeom>
+            <a:rect b="b" l="l" r="r" t="t"/>
+            <a:pathLst>
+              <a:path extrusionOk="0" h="120000" w="120000">
+                <a:moveTo>
+                  <a:pt x="0" y="0"/>
+                </a:moveTo>
+                <a:lnTo>
+                  <a:pt x="120000" y="0"/>
+                </a:lnTo>
+                <a:lnTo>
+                  <a:pt x="120000" y="120000"/>
+                </a:lnTo>
+                <a:lnTo>
+                  <a:pt x="0" y="120000"/>
+                </a:lnTo>
+                <a:close/>
+              </a:path>
+            </a:pathLst>
+          </a:custGeom>
+        </p:spPr>
+      </p:sp>
+      <p:sp>
+        <p:nvSpPr>
+          <p:cNvPr id="219" name="Google Shape;219;g3f56af012ea_0_21:notes"/>
+          <p:cNvSpPr txBox="1"/>
+          <p:nvPr>
+            <p:ph idx="1" type="body"/>
+          </p:nvPr>
+        </p:nvSpPr>
+        <p:spPr>
+          <a:xfrm>
+            <a:off x="685800" y="4343400"/>
+            <a:ext cx="5486400" cy="4114800"/>
+          </a:xfrm>
+          <a:prstGeom prst="rect">
+            <a:avLst/>
+          </a:prstGeom>
+        </p:spPr>
+        <p:txBody>
+          <a:bodyPr anchorCtr="0" anchor="t" bIns="91425" lIns="91425" spcFirstLastPara="1" rIns="91425" wrap="square" tIns="91425">
+            <a:noAutofit/>
+          </a:bodyPr>
+          <a:lstStyle/>
+          <a:p>
+            <a:pPr indent="0" lvl="0" marL="0" rtl="0" algn="l">
+              <a:spcBef>
+                <a:spcPts val="0"/>
+              </a:spcBef>
+              <a:spcAft>
+                <a:spcPts val="0"/>
+              </a:spcAft>
+              <a:buNone/>
+            </a:pPr>
+            <a:r>
+              <a:t/>
+            </a:r>
+            <a:endParaRPr/>
+          </a:p>
+        </p:txBody>
+      </p:sp>
+    </p:spTree>
+  </p:cSld>
+  <p:clrMapOvr>
+    <a:masterClrMapping/>
+  </p:clrMapOvr>
+</p:notes>
+</file>
+
+<file path=ppt/notesSlides/notesSlide19.xml><?xml version="1.0" encoding="utf-8"?>
+<p:notes xmlns:a="http://schemas.openxmlformats.org/drawingml/2006/main" xmlns:r="http://schemas.openxmlformats.org/officeDocument/2006/relationships" xmlns:mc="http://schemas.openxmlformats.org/markup-compatibility/2006" xmlns:mv="urn:schemas-microsoft-com:mac:vml" xmlns:p="http://schemas.openxmlformats.org/presentationml/2006/main" xmlns:c="http://schemas.openxmlformats.org/drawingml/2006/chart" xmlns:dgm="http://schemas.openxmlformats.org/drawingml/2006/diagram" xmlns:o="urn:schemas-microsoft-com:office:office" xmlns:v="urn:schemas-microsoft-com:vml" xmlns:pvml="urn:schemas-microsoft-com:office:powerpoint" xmlns:com="http://schemas.openxmlformats.org/drawingml/2006/compatibility" xmlns:p14="http://schemas.microsoft.com/office/powerpoint/2010/main" xmlns:p15="http://schemas.microsoft.com/office/powerpoint/2012/main" xmlns:ahyp="http://schemas.microsoft.com/office/drawing/2018/hyperlinkcolor" showMasterPhAnim="0" showMasterSp="0">
+  <p:cSld>
+    <p:spTree>
+      <p:nvGrpSpPr>
+        <p:cNvPr id="226" name="Shape 226"/>
+        <p:cNvGrpSpPr/>
+        <p:nvPr/>
+      </p:nvGrpSpPr>
+      <p:grpSpPr>
+        <a:xfrm>
+          <a:off x="0" y="0"/>
+          <a:ext cx="0" cy="0"/>
+          <a:chOff x="0" y="0"/>
+          <a:chExt cx="0" cy="0"/>
+        </a:xfrm>
+      </p:grpSpPr>
+      <p:sp>
+        <p:nvSpPr>
+          <p:cNvPr id="227" name="Google Shape;227;g3edf06be40a_0_383:notes"/>
+          <p:cNvSpPr/>
+          <p:nvPr>
+            <p:ph idx="2" type="sldImg"/>
+          </p:nvPr>
+        </p:nvSpPr>
+        <p:spPr>
+          <a:xfrm>
+            <a:off x="381300" y="685800"/>
+            <a:ext cx="6096000" cy="3429000"/>
+          </a:xfrm>
+          <a:custGeom>
+            <a:rect b="b" l="l" r="r" t="t"/>
+            <a:pathLst>
+              <a:path extrusionOk="0" h="120000" w="120000">
+                <a:moveTo>
+                  <a:pt x="0" y="0"/>
+                </a:moveTo>
+                <a:lnTo>
+                  <a:pt x="120000" y="0"/>
+                </a:lnTo>
+                <a:lnTo>
+                  <a:pt x="120000" y="120000"/>
+                </a:lnTo>
+                <a:lnTo>
+                  <a:pt x="0" y="120000"/>
+                </a:lnTo>
+                <a:close/>
+              </a:path>
+            </a:pathLst>
+          </a:custGeom>
+        </p:spPr>
+      </p:sp>
+      <p:sp>
+        <p:nvSpPr>
+          <p:cNvPr id="228" name="Google Shape;228;g3edf06be40a_0_383:notes"/>
           <p:cNvSpPr txBox="1"/>
           <p:nvPr>
             <p:ph idx="1" type="body"/>
@@ -7522,8 +7822,8 @@
         </p:nvSpPr>
         <p:spPr>
           <a:xfrm>
-            <a:off x="365400" y="2525"/>
-            <a:ext cx="8454600" cy="720000"/>
+            <a:off x="264089" y="2525"/>
+            <a:ext cx="8659800" cy="720000"/>
           </a:xfrm>
           <a:prstGeom prst="rect">
             <a:avLst/>
@@ -7558,7 +7858,7 @@
                 <a:cs typeface="Roboto Light"/>
                 <a:sym typeface="Roboto Light"/>
               </a:rPr>
-              <a:t>Premier modèle KMeans (jeudi sept 2014 HPS 16-19h)</a:t>
+              <a:t>Choix du nombre de clusters : WCSS method + silhouette score</a:t>
             </a:r>
             <a:endParaRPr sz="2400">
               <a:solidFill>
@@ -7575,360 +7875,6 @@
       <p:sp>
         <p:nvSpPr>
           <p:cNvPr id="145" name="Google Shape;145;p22"/>
-          <p:cNvSpPr txBox="1"/>
-          <p:nvPr/>
-        </p:nvSpPr>
-        <p:spPr>
-          <a:xfrm>
-            <a:off x="6408525" y="833300"/>
-            <a:ext cx="2671800" cy="3847800"/>
-          </a:xfrm>
-          <a:prstGeom prst="rect">
-            <a:avLst/>
-          </a:prstGeom>
-          <a:noFill/>
-          <a:ln>
-            <a:noFill/>
-          </a:ln>
-        </p:spPr>
-        <p:txBody>
-          <a:bodyPr anchorCtr="0" anchor="t" bIns="91425" lIns="91425" spcFirstLastPara="1" rIns="91425" wrap="square" tIns="91425">
-            <a:noAutofit/>
-          </a:bodyPr>
-          <a:lstStyle/>
-          <a:p>
-            <a:pPr indent="-349250" lvl="0" marL="457200" rtl="0" algn="l">
-              <a:spcBef>
-                <a:spcPts val="0"/>
-              </a:spcBef>
-              <a:spcAft>
-                <a:spcPts val="0"/>
-              </a:spcAft>
-              <a:buClr>
-                <a:schemeClr val="dk2"/>
-              </a:buClr>
-              <a:buSzPts val="1900"/>
-              <a:buFont typeface="Calibri"/>
-              <a:buChar char="●"/>
-            </a:pPr>
-            <a:r>
-              <a:rPr lang="fr" sz="1900">
-                <a:solidFill>
-                  <a:schemeClr val="dk2"/>
-                </a:solidFill>
-                <a:latin typeface="Calibri"/>
-                <a:ea typeface="Calibri"/>
-                <a:cs typeface="Calibri"/>
-                <a:sym typeface="Calibri"/>
-              </a:rPr>
-              <a:t>k = 20 clusters</a:t>
-            </a:r>
-            <a:endParaRPr sz="1900">
-              <a:solidFill>
-                <a:schemeClr val="dk2"/>
-              </a:solidFill>
-              <a:latin typeface="Calibri"/>
-              <a:ea typeface="Calibri"/>
-              <a:cs typeface="Calibri"/>
-              <a:sym typeface="Calibri"/>
-            </a:endParaRPr>
-          </a:p>
-          <a:p>
-            <a:pPr indent="-349250" lvl="0" marL="457200" rtl="0" algn="l">
-              <a:spcBef>
-                <a:spcPts val="0"/>
-              </a:spcBef>
-              <a:spcAft>
-                <a:spcPts val="0"/>
-              </a:spcAft>
-              <a:buClr>
-                <a:schemeClr val="dk2"/>
-              </a:buClr>
-              <a:buSzPts val="1900"/>
-              <a:buFont typeface="Calibri"/>
-              <a:buChar char="●"/>
-            </a:pPr>
-            <a:r>
-              <a:rPr lang="fr" sz="1900">
-                <a:solidFill>
-                  <a:schemeClr val="dk2"/>
-                </a:solidFill>
-                <a:latin typeface="Calibri"/>
-                <a:ea typeface="Calibri"/>
-                <a:cs typeface="Calibri"/>
-                <a:sym typeface="Calibri"/>
-              </a:rPr>
-              <a:t>metric=manhattan</a:t>
-            </a:r>
-            <a:endParaRPr sz="1900">
-              <a:solidFill>
-                <a:schemeClr val="dk2"/>
-              </a:solidFill>
-              <a:latin typeface="Calibri"/>
-              <a:ea typeface="Calibri"/>
-              <a:cs typeface="Calibri"/>
-              <a:sym typeface="Calibri"/>
-            </a:endParaRPr>
-          </a:p>
-          <a:p>
-            <a:pPr indent="-349250" lvl="0" marL="457200" rtl="0" algn="l">
-              <a:spcBef>
-                <a:spcPts val="0"/>
-              </a:spcBef>
-              <a:spcAft>
-                <a:spcPts val="0"/>
-              </a:spcAft>
-              <a:buClr>
-                <a:schemeClr val="dk2"/>
-              </a:buClr>
-              <a:buSzPts val="1900"/>
-              <a:buFont typeface="Calibri"/>
-              <a:buChar char="●"/>
-            </a:pPr>
-            <a:r>
-              <a:rPr lang="fr" sz="1900">
-                <a:solidFill>
-                  <a:schemeClr val="dk2"/>
-                </a:solidFill>
-                <a:latin typeface="Calibri"/>
-                <a:ea typeface="Calibri"/>
-                <a:cs typeface="Calibri"/>
-                <a:sym typeface="Calibri"/>
-              </a:rPr>
-              <a:t>1000 iterations</a:t>
-            </a:r>
-            <a:endParaRPr sz="1900">
-              <a:solidFill>
-                <a:schemeClr val="dk2"/>
-              </a:solidFill>
-              <a:latin typeface="Calibri"/>
-              <a:ea typeface="Calibri"/>
-              <a:cs typeface="Calibri"/>
-              <a:sym typeface="Calibri"/>
-            </a:endParaRPr>
-          </a:p>
-          <a:p>
-            <a:pPr indent="0" lvl="0" marL="457200" rtl="0" algn="l">
-              <a:spcBef>
-                <a:spcPts val="0"/>
-              </a:spcBef>
-              <a:spcAft>
-                <a:spcPts val="0"/>
-              </a:spcAft>
-              <a:buNone/>
-            </a:pPr>
-            <a:r>
-              <a:t/>
-            </a:r>
-            <a:endParaRPr sz="1900">
-              <a:solidFill>
-                <a:schemeClr val="dk2"/>
-              </a:solidFill>
-              <a:latin typeface="Calibri"/>
-              <a:ea typeface="Calibri"/>
-              <a:cs typeface="Calibri"/>
-              <a:sym typeface="Calibri"/>
-            </a:endParaRPr>
-          </a:p>
-          <a:p>
-            <a:pPr indent="0" lvl="0" marL="0" rtl="0" algn="l">
-              <a:spcBef>
-                <a:spcPts val="0"/>
-              </a:spcBef>
-              <a:spcAft>
-                <a:spcPts val="0"/>
-              </a:spcAft>
-              <a:buNone/>
-            </a:pPr>
-            <a:r>
-              <a:t/>
-            </a:r>
-            <a:endParaRPr sz="1900">
-              <a:solidFill>
-                <a:schemeClr val="dk2"/>
-              </a:solidFill>
-              <a:latin typeface="Calibri"/>
-              <a:ea typeface="Calibri"/>
-              <a:cs typeface="Calibri"/>
-              <a:sym typeface="Calibri"/>
-            </a:endParaRPr>
-          </a:p>
-          <a:p>
-            <a:pPr indent="-349250" lvl="0" marL="457200" rtl="0" algn="l">
-              <a:spcBef>
-                <a:spcPts val="0"/>
-              </a:spcBef>
-              <a:spcAft>
-                <a:spcPts val="0"/>
-              </a:spcAft>
-              <a:buClr>
-                <a:schemeClr val="dk2"/>
-              </a:buClr>
-              <a:buSzPts val="1900"/>
-              <a:buFont typeface="Calibri"/>
-              <a:buChar char="●"/>
-            </a:pPr>
-            <a:r>
-              <a:rPr lang="fr" sz="1900">
-                <a:solidFill>
-                  <a:schemeClr val="dk2"/>
-                </a:solidFill>
-                <a:latin typeface="Calibri"/>
-                <a:ea typeface="Calibri"/>
-                <a:cs typeface="Calibri"/>
-                <a:sym typeface="Calibri"/>
-              </a:rPr>
-              <a:t>NYC trop compacte et concentrée</a:t>
-            </a:r>
-            <a:endParaRPr sz="1900">
-              <a:solidFill>
-                <a:schemeClr val="dk2"/>
-              </a:solidFill>
-              <a:latin typeface="Calibri"/>
-              <a:ea typeface="Calibri"/>
-              <a:cs typeface="Calibri"/>
-              <a:sym typeface="Calibri"/>
-            </a:endParaRPr>
-          </a:p>
-          <a:p>
-            <a:pPr indent="-349250" lvl="0" marL="457200" rtl="0" algn="l">
-              <a:spcBef>
-                <a:spcPts val="0"/>
-              </a:spcBef>
-              <a:spcAft>
-                <a:spcPts val="0"/>
-              </a:spcAft>
-              <a:buClr>
-                <a:schemeClr val="dk2"/>
-              </a:buClr>
-              <a:buSzPts val="1900"/>
-              <a:buFont typeface="Calibri"/>
-              <a:buChar char="●"/>
-            </a:pPr>
-            <a:r>
-              <a:rPr lang="fr" sz="1900">
-                <a:solidFill>
-                  <a:schemeClr val="dk2"/>
-                </a:solidFill>
-                <a:latin typeface="Calibri"/>
-                <a:ea typeface="Calibri"/>
-                <a:cs typeface="Calibri"/>
-                <a:sym typeface="Calibri"/>
-              </a:rPr>
-              <a:t>lecture difficile</a:t>
-            </a:r>
-            <a:endParaRPr sz="1900">
-              <a:solidFill>
-                <a:schemeClr val="dk2"/>
-              </a:solidFill>
-              <a:latin typeface="Calibri"/>
-              <a:ea typeface="Calibri"/>
-              <a:cs typeface="Calibri"/>
-              <a:sym typeface="Calibri"/>
-            </a:endParaRPr>
-          </a:p>
-          <a:p>
-            <a:pPr indent="-349250" lvl="0" marL="457200" rtl="0" algn="l">
-              <a:spcBef>
-                <a:spcPts val="0"/>
-              </a:spcBef>
-              <a:spcAft>
-                <a:spcPts val="0"/>
-              </a:spcAft>
-              <a:buClr>
-                <a:schemeClr val="dk2"/>
-              </a:buClr>
-              <a:buSzPts val="1900"/>
-              <a:buFont typeface="Calibri"/>
-              <a:buChar char="●"/>
-            </a:pPr>
-            <a:r>
-              <a:rPr lang="fr" sz="1900">
-                <a:solidFill>
-                  <a:schemeClr val="dk2"/>
-                </a:solidFill>
-                <a:latin typeface="Calibri"/>
-                <a:ea typeface="Calibri"/>
-                <a:cs typeface="Calibri"/>
-                <a:sym typeface="Calibri"/>
-              </a:rPr>
-              <a:t>difficulté sur le choix du nombre de clusters</a:t>
-            </a:r>
-            <a:endParaRPr sz="1900">
-              <a:solidFill>
-                <a:schemeClr val="dk2"/>
-              </a:solidFill>
-              <a:latin typeface="Calibri"/>
-              <a:ea typeface="Calibri"/>
-              <a:cs typeface="Calibri"/>
-              <a:sym typeface="Calibri"/>
-            </a:endParaRPr>
-          </a:p>
-          <a:p>
-            <a:pPr indent="-349250" lvl="0" marL="457200" rtl="0" algn="l">
-              <a:spcBef>
-                <a:spcPts val="0"/>
-              </a:spcBef>
-              <a:spcAft>
-                <a:spcPts val="0"/>
-              </a:spcAft>
-              <a:buClr>
-                <a:schemeClr val="dk2"/>
-              </a:buClr>
-              <a:buSzPts val="1900"/>
-              <a:buFont typeface="Calibri"/>
-              <a:buChar char="●"/>
-            </a:pPr>
-            <a:r>
-              <a:rPr lang="fr" sz="1900">
-                <a:solidFill>
-                  <a:schemeClr val="dk2"/>
-                </a:solidFill>
-                <a:latin typeface="Calibri"/>
-                <a:ea typeface="Calibri"/>
-                <a:cs typeface="Calibri"/>
-                <a:sym typeface="Calibri"/>
-              </a:rPr>
-              <a:t>sensible aux outliers</a:t>
-            </a:r>
-            <a:endParaRPr sz="1900">
-              <a:solidFill>
-                <a:schemeClr val="dk2"/>
-              </a:solidFill>
-              <a:latin typeface="Calibri"/>
-              <a:ea typeface="Calibri"/>
-              <a:cs typeface="Calibri"/>
-              <a:sym typeface="Calibri"/>
-            </a:endParaRPr>
-          </a:p>
-          <a:p>
-            <a:pPr indent="0" lvl="0" marL="0" rtl="0" algn="l">
-              <a:spcBef>
-                <a:spcPts val="0"/>
-              </a:spcBef>
-              <a:spcAft>
-                <a:spcPts val="0"/>
-              </a:spcAft>
-              <a:buNone/>
-            </a:pPr>
-            <a:r>
-              <a:t/>
-            </a:r>
-            <a:endParaRPr sz="1900">
-              <a:solidFill>
-                <a:schemeClr val="dk2"/>
-              </a:solidFill>
-              <a:latin typeface="Calibri"/>
-              <a:ea typeface="Calibri"/>
-              <a:cs typeface="Calibri"/>
-              <a:sym typeface="Calibri"/>
-            </a:endParaRPr>
-          </a:p>
-        </p:txBody>
-      </p:sp>
-      <p:sp>
-        <p:nvSpPr>
-          <p:cNvPr id="146" name="Google Shape;146;p22"/>
           <p:cNvSpPr/>
           <p:nvPr/>
         </p:nvSpPr>
@@ -7977,7 +7923,7 @@
       </p:sp>
       <p:sp>
         <p:nvSpPr>
-          <p:cNvPr id="147" name="Google Shape;147;p22"/>
+          <p:cNvPr id="146" name="Google Shape;146;p22"/>
           <p:cNvSpPr txBox="1"/>
           <p:nvPr/>
         </p:nvSpPr>
@@ -8035,7 +7981,7 @@
       </p:sp>
       <p:pic>
         <p:nvPicPr>
-          <p:cNvPr id="148" name="Google Shape;148;p22"/>
+          <p:cNvPr id="147" name="Google Shape;147;p22" title="kmeans_wss_elbow.png"/>
           <p:cNvPicPr preferRelativeResize="0"/>
           <p:nvPr/>
         </p:nvPicPr>
@@ -8049,8 +7995,8 @@
         </p:blipFill>
         <p:spPr>
           <a:xfrm>
-            <a:off x="152400" y="874925"/>
-            <a:ext cx="6318207" cy="3895075"/>
+            <a:off x="4980500" y="927425"/>
+            <a:ext cx="4108950" cy="2282741"/>
           </a:xfrm>
           <a:prstGeom prst="rect">
             <a:avLst/>
@@ -8061,6 +8007,168 @@
           </a:ln>
         </p:spPr>
       </p:pic>
+      <p:pic>
+        <p:nvPicPr>
+          <p:cNvPr id="148" name="Google Shape;148;p22" title="kmeans_silhouette.png"/>
+          <p:cNvPicPr preferRelativeResize="0"/>
+          <p:nvPr/>
+        </p:nvPicPr>
+        <p:blipFill>
+          <a:blip r:embed="rId4">
+            <a:alphaModFix/>
+          </a:blip>
+          <a:stretch>
+            <a:fillRect/>
+          </a:stretch>
+        </p:blipFill>
+        <p:spPr>
+          <a:xfrm>
+            <a:off x="-5730" y="722524"/>
+            <a:ext cx="5048575" cy="2804775"/>
+          </a:xfrm>
+          <a:prstGeom prst="rect">
+            <a:avLst/>
+          </a:prstGeom>
+          <a:noFill/>
+          <a:ln>
+            <a:noFill/>
+          </a:ln>
+        </p:spPr>
+      </p:pic>
+      <p:sp>
+        <p:nvSpPr>
+          <p:cNvPr id="149" name="Google Shape;149;p22"/>
+          <p:cNvSpPr txBox="1"/>
+          <p:nvPr/>
+        </p:nvSpPr>
+        <p:spPr>
+          <a:xfrm>
+            <a:off x="546175" y="3477050"/>
+            <a:ext cx="8221800" cy="1200000"/>
+          </a:xfrm>
+          <a:prstGeom prst="rect">
+            <a:avLst/>
+          </a:prstGeom>
+          <a:noFill/>
+          <a:ln>
+            <a:noFill/>
+          </a:ln>
+        </p:spPr>
+        <p:txBody>
+          <a:bodyPr anchorCtr="0" anchor="t" bIns="91425" lIns="91425" spcFirstLastPara="1" rIns="91425" wrap="square" tIns="91425">
+            <a:noAutofit/>
+          </a:bodyPr>
+          <a:lstStyle/>
+          <a:p>
+            <a:pPr indent="-336550" lvl="0" marL="457200" rtl="0" algn="l">
+              <a:spcBef>
+                <a:spcPts val="0"/>
+              </a:spcBef>
+              <a:spcAft>
+                <a:spcPts val="0"/>
+              </a:spcAft>
+              <a:buClr>
+                <a:schemeClr val="dk2"/>
+              </a:buClr>
+              <a:buSzPts val="1700"/>
+              <a:buChar char="●"/>
+            </a:pPr>
+            <a:r>
+              <a:rPr lang="fr" sz="1700">
+                <a:solidFill>
+                  <a:schemeClr val="dk2"/>
+                </a:solidFill>
+              </a:rPr>
+              <a:t>Silhouette score chute fortement jusqu'à k≈8–10 (mais cluster trop larges)</a:t>
+            </a:r>
+            <a:endParaRPr sz="1700">
+              <a:solidFill>
+                <a:schemeClr val="dk2"/>
+              </a:solidFill>
+            </a:endParaRPr>
+          </a:p>
+          <a:p>
+            <a:pPr indent="-336550" lvl="0" marL="457200" rtl="0" algn="l">
+              <a:spcBef>
+                <a:spcPts val="0"/>
+              </a:spcBef>
+              <a:spcAft>
+                <a:spcPts val="0"/>
+              </a:spcAft>
+              <a:buClr>
+                <a:schemeClr val="dk2"/>
+              </a:buClr>
+              <a:buSzPts val="1700"/>
+              <a:buChar char="●"/>
+            </a:pPr>
+            <a:r>
+              <a:rPr lang="fr" sz="1700">
+                <a:solidFill>
+                  <a:schemeClr val="dk2"/>
+                </a:solidFill>
+              </a:rPr>
+              <a:t>puis chute encore vers k=21</a:t>
+            </a:r>
+            <a:endParaRPr sz="1700">
+              <a:solidFill>
+                <a:schemeClr val="dk2"/>
+              </a:solidFill>
+            </a:endParaRPr>
+          </a:p>
+          <a:p>
+            <a:pPr indent="-336550" lvl="0" marL="457200" rtl="0" algn="l">
+              <a:spcBef>
+                <a:spcPts val="0"/>
+              </a:spcBef>
+              <a:spcAft>
+                <a:spcPts val="0"/>
+              </a:spcAft>
+              <a:buClr>
+                <a:schemeClr val="dk2"/>
+              </a:buClr>
+              <a:buSzPts val="1700"/>
+              <a:buChar char="●"/>
+            </a:pPr>
+            <a:r>
+              <a:rPr lang="fr" sz="1700">
+                <a:solidFill>
+                  <a:schemeClr val="dk2"/>
+                </a:solidFill>
+              </a:rPr>
+              <a:t>WCSS ne diminue plus notablement au delà de k=15</a:t>
+            </a:r>
+            <a:endParaRPr sz="1700">
+              <a:solidFill>
+                <a:schemeClr val="dk2"/>
+              </a:solidFill>
+            </a:endParaRPr>
+          </a:p>
+          <a:p>
+            <a:pPr indent="0" lvl="0" marL="0" rtl="0" algn="l">
+              <a:spcBef>
+                <a:spcPts val="0"/>
+              </a:spcBef>
+              <a:spcAft>
+                <a:spcPts val="0"/>
+              </a:spcAft>
+              <a:buNone/>
+            </a:pPr>
+            <a:r>
+              <a:rPr lang="fr" sz="1700">
+                <a:solidFill>
+                  <a:schemeClr val="dk2"/>
+                </a:solidFill>
+              </a:rPr>
+              <a:t>→ on choisira k=21 comme nombre de clusters</a:t>
+            </a:r>
+            <a:endParaRPr sz="1700">
+              <a:solidFill>
+                <a:schemeClr val="dk2"/>
+              </a:solidFill>
+            </a:endParaRPr>
+          </a:p>
+        </p:txBody>
+      </p:sp>
     </p:spTree>
   </p:cSld>
   <p:clrMapOvr>
@@ -8081,7 +8189,7 @@
     </p:bg>
     <p:spTree>
       <p:nvGrpSpPr>
-        <p:cNvPr id="152" name="Shape 152"/>
+        <p:cNvPr id="153" name="Shape 153"/>
         <p:cNvGrpSpPr/>
         <p:nvPr/>
       </p:nvGrpSpPr>
@@ -8095,7 +8203,7 @@
       </p:grpSpPr>
       <p:sp>
         <p:nvSpPr>
-          <p:cNvPr id="153" name="Google Shape;153;p23"/>
+          <p:cNvPr id="154" name="Google Shape;154;p23"/>
           <p:cNvSpPr/>
           <p:nvPr/>
         </p:nvSpPr>
@@ -8144,7 +8252,7 @@
       </p:sp>
       <p:sp>
         <p:nvSpPr>
-          <p:cNvPr id="154" name="Google Shape;154;p23"/>
+          <p:cNvPr id="155" name="Google Shape;155;p23"/>
           <p:cNvSpPr txBox="1"/>
           <p:nvPr/>
         </p:nvSpPr>
@@ -8202,14 +8310,14 @@
       </p:sp>
       <p:sp>
         <p:nvSpPr>
-          <p:cNvPr id="155" name="Google Shape;155;p23"/>
+          <p:cNvPr id="156" name="Google Shape;156;p23"/>
           <p:cNvSpPr txBox="1"/>
           <p:nvPr/>
         </p:nvSpPr>
         <p:spPr>
           <a:xfrm>
-            <a:off x="5877250" y="874926"/>
-            <a:ext cx="3194100" cy="3621000"/>
+            <a:off x="5822900" y="833300"/>
+            <a:ext cx="3257400" cy="3847800"/>
           </a:xfrm>
           <a:prstGeom prst="rect">
             <a:avLst/>
@@ -8249,31 +8357,7 @@
                 <a:cs typeface="Calibri"/>
                 <a:sym typeface="Calibri"/>
               </a:rPr>
-              <a:t>affichage des </a:t>
-            </a:r>
-            <a:r>
-              <a:rPr lang="fr" sz="1900">
-                <a:solidFill>
-                  <a:schemeClr val="dk2"/>
-                </a:solidFill>
-                <a:latin typeface="Calibri"/>
-                <a:ea typeface="Calibri"/>
-                <a:cs typeface="Calibri"/>
-                <a:sym typeface="Calibri"/>
-              </a:rPr>
-              <a:t>centroïdes</a:t>
-            </a:r>
-            <a:r>
-              <a:rPr lang="fr" sz="1900">
-                <a:solidFill>
-                  <a:schemeClr val="dk2"/>
-                </a:solidFill>
-                <a:latin typeface="Calibri"/>
-                <a:ea typeface="Calibri"/>
-                <a:cs typeface="Calibri"/>
-                <a:sym typeface="Calibri"/>
-              </a:rPr>
-              <a:t> avec leurs poids respectifs</a:t>
+              <a:t>k = 21 clusters</a:t>
             </a:r>
             <a:endParaRPr sz="1900">
               <a:solidFill>
@@ -8310,7 +8394,7 @@
                 <a:cs typeface="Calibri"/>
                 <a:sym typeface="Calibri"/>
               </a:rPr>
-              <a:t>permet meilleure visu des hot-zones</a:t>
+              <a:t>metric=manhattan</a:t>
             </a:r>
             <a:endParaRPr sz="1900">
               <a:solidFill>
@@ -8323,17 +8407,31 @@
             </a:endParaRPr>
           </a:p>
           <a:p>
-            <a:pPr indent="0" lvl="0" marL="0" rtl="0" algn="l">
-              <a:spcBef>
-                <a:spcPts val="0"/>
-              </a:spcBef>
-              <a:spcAft>
-                <a:spcPts val="0"/>
-              </a:spcAft>
-              <a:buNone/>
-            </a:pPr>
-            <a:r>
-              <a:t/>
+            <a:pPr indent="-349250" lvl="0" marL="457200" rtl="0" algn="l">
+              <a:spcBef>
+                <a:spcPts val="0"/>
+              </a:spcBef>
+              <a:spcAft>
+                <a:spcPts val="0"/>
+              </a:spcAft>
+              <a:buClr>
+                <a:schemeClr val="dk2"/>
+              </a:buClr>
+              <a:buSzPts val="1900"/>
+              <a:buFont typeface="Calibri"/>
+              <a:buChar char="●"/>
+            </a:pPr>
+            <a:r>
+              <a:rPr lang="fr" sz="1900">
+                <a:solidFill>
+                  <a:schemeClr val="dk2"/>
+                </a:solidFill>
+                <a:latin typeface="Calibri"/>
+                <a:ea typeface="Calibri"/>
+                <a:cs typeface="Calibri"/>
+                <a:sym typeface="Calibri"/>
+              </a:rPr>
+              <a:t>1000 iterations</a:t>
             </a:r>
             <a:endParaRPr sz="1900">
               <a:solidFill>
@@ -8346,31 +8444,17 @@
             </a:endParaRPr>
           </a:p>
           <a:p>
-            <a:pPr indent="-349250" lvl="0" marL="457200" rtl="0" algn="l">
-              <a:spcBef>
-                <a:spcPts val="0"/>
-              </a:spcBef>
-              <a:spcAft>
-                <a:spcPts val="0"/>
-              </a:spcAft>
-              <a:buClr>
-                <a:schemeClr val="dk2"/>
-              </a:buClr>
-              <a:buSzPts val="1900"/>
-              <a:buFont typeface="Calibri"/>
-              <a:buChar char="●"/>
-            </a:pPr>
-            <a:r>
-              <a:rPr lang="fr" sz="1900">
-                <a:solidFill>
-                  <a:schemeClr val="dk2"/>
-                </a:solidFill>
-                <a:latin typeface="Calibri"/>
-                <a:ea typeface="Calibri"/>
-                <a:cs typeface="Calibri"/>
-                <a:sym typeface="Calibri"/>
-              </a:rPr>
-              <a:t>préférable d’ajouter polygones des hot-zones</a:t>
+            <a:pPr indent="0" lvl="0" marL="457200" rtl="0" algn="l">
+              <a:spcBef>
+                <a:spcPts val="0"/>
+              </a:spcBef>
+              <a:spcAft>
+                <a:spcPts val="0"/>
+              </a:spcAft>
+              <a:buNone/>
+            </a:pPr>
+            <a:r>
+              <a:t/>
             </a:r>
             <a:endParaRPr sz="1900">
               <a:solidFill>
@@ -8383,19 +8467,14 @@
             </a:endParaRPr>
           </a:p>
           <a:p>
-            <a:pPr indent="-349250" lvl="0" marL="457200" rtl="0" algn="l">
-              <a:spcBef>
-                <a:spcPts val="0"/>
-              </a:spcBef>
-              <a:spcAft>
-                <a:spcPts val="0"/>
-              </a:spcAft>
-              <a:buClr>
-                <a:schemeClr val="dk2"/>
-              </a:buClr>
-              <a:buSzPts val="1900"/>
-              <a:buFont typeface="Calibri"/>
-              <a:buChar char="●"/>
+            <a:pPr indent="0" lvl="0" marL="0" rtl="0" algn="l">
+              <a:spcBef>
+                <a:spcPts val="0"/>
+              </a:spcBef>
+              <a:spcAft>
+                <a:spcPts val="0"/>
+              </a:spcAft>
+              <a:buNone/>
             </a:pPr>
             <a:r>
               <a:rPr lang="fr" sz="1900">
@@ -8407,7 +8486,7 @@
                 <a:cs typeface="Calibri"/>
                 <a:sym typeface="Calibri"/>
               </a:rPr>
-              <a:t>+ la densité des courses/m2</a:t>
+              <a:t>mais…</a:t>
             </a:r>
             <a:endParaRPr sz="1900">
               <a:solidFill>
@@ -8444,31 +8523,7 @@
                 <a:cs typeface="Calibri"/>
                 <a:sym typeface="Calibri"/>
               </a:rPr>
-              <a:t>adaptation taille </a:t>
-            </a:r>
-            <a:r>
-              <a:rPr lang="fr" sz="1900">
-                <a:solidFill>
-                  <a:schemeClr val="dk2"/>
-                </a:solidFill>
-                <a:latin typeface="Calibri"/>
-                <a:ea typeface="Calibri"/>
-                <a:cs typeface="Calibri"/>
-                <a:sym typeface="Calibri"/>
-              </a:rPr>
-              <a:t>centroïdes</a:t>
-            </a:r>
-            <a:r>
-              <a:rPr lang="fr" sz="1900">
-                <a:solidFill>
-                  <a:schemeClr val="dk2"/>
-                </a:solidFill>
-                <a:latin typeface="Calibri"/>
-                <a:ea typeface="Calibri"/>
-                <a:cs typeface="Calibri"/>
-                <a:sym typeface="Calibri"/>
-              </a:rPr>
-              <a:t> / zoom</a:t>
+              <a:t>NYC trop compacte et concentrée</a:t>
             </a:r>
             <a:endParaRPr sz="1900">
               <a:solidFill>
@@ -8480,11 +8535,145 @@
               <a:sym typeface="Calibri"/>
             </a:endParaRPr>
           </a:p>
+          <a:p>
+            <a:pPr indent="-349250" lvl="0" marL="457200" rtl="0" algn="l">
+              <a:spcBef>
+                <a:spcPts val="0"/>
+              </a:spcBef>
+              <a:spcAft>
+                <a:spcPts val="0"/>
+              </a:spcAft>
+              <a:buClr>
+                <a:schemeClr val="dk2"/>
+              </a:buClr>
+              <a:buSzPts val="1900"/>
+              <a:buFont typeface="Calibri"/>
+              <a:buChar char="●"/>
+            </a:pPr>
+            <a:r>
+              <a:rPr lang="fr" sz="1900">
+                <a:solidFill>
+                  <a:schemeClr val="dk2"/>
+                </a:solidFill>
+                <a:latin typeface="Calibri"/>
+                <a:ea typeface="Calibri"/>
+                <a:cs typeface="Calibri"/>
+                <a:sym typeface="Calibri"/>
+              </a:rPr>
+              <a:t>lecture difficile</a:t>
+            </a:r>
+            <a:endParaRPr sz="1900">
+              <a:solidFill>
+                <a:schemeClr val="dk2"/>
+              </a:solidFill>
+              <a:latin typeface="Calibri"/>
+              <a:ea typeface="Calibri"/>
+              <a:cs typeface="Calibri"/>
+              <a:sym typeface="Calibri"/>
+            </a:endParaRPr>
+          </a:p>
+          <a:p>
+            <a:pPr indent="-349250" lvl="0" marL="457200" rtl="0" algn="l">
+              <a:spcBef>
+                <a:spcPts val="0"/>
+              </a:spcBef>
+              <a:spcAft>
+                <a:spcPts val="0"/>
+              </a:spcAft>
+              <a:buClr>
+                <a:schemeClr val="dk2"/>
+              </a:buClr>
+              <a:buSzPts val="1900"/>
+              <a:buFont typeface="Calibri"/>
+              <a:buChar char="●"/>
+            </a:pPr>
+            <a:r>
+              <a:rPr lang="fr" sz="1900">
+                <a:solidFill>
+                  <a:schemeClr val="dk2"/>
+                </a:solidFill>
+                <a:latin typeface="Calibri"/>
+                <a:ea typeface="Calibri"/>
+                <a:cs typeface="Calibri"/>
+                <a:sym typeface="Calibri"/>
+              </a:rPr>
+              <a:t>difficulté sur le choix du nombre de clusters</a:t>
+            </a:r>
+            <a:endParaRPr sz="1900">
+              <a:solidFill>
+                <a:schemeClr val="dk2"/>
+              </a:solidFill>
+              <a:latin typeface="Calibri"/>
+              <a:ea typeface="Calibri"/>
+              <a:cs typeface="Calibri"/>
+              <a:sym typeface="Calibri"/>
+            </a:endParaRPr>
+          </a:p>
+          <a:p>
+            <a:pPr indent="-349250" lvl="0" marL="457200" rtl="0" algn="l">
+              <a:spcBef>
+                <a:spcPts val="0"/>
+              </a:spcBef>
+              <a:spcAft>
+                <a:spcPts val="0"/>
+              </a:spcAft>
+              <a:buClr>
+                <a:schemeClr val="dk2"/>
+              </a:buClr>
+              <a:buSzPts val="1900"/>
+              <a:buFont typeface="Calibri"/>
+              <a:buChar char="●"/>
+            </a:pPr>
+            <a:r>
+              <a:rPr lang="fr" sz="1900">
+                <a:solidFill>
+                  <a:schemeClr val="dk2"/>
+                </a:solidFill>
+                <a:latin typeface="Calibri"/>
+                <a:ea typeface="Calibri"/>
+                <a:cs typeface="Calibri"/>
+                <a:sym typeface="Calibri"/>
+              </a:rPr>
+              <a:t>sensible aux outliers</a:t>
+            </a:r>
+            <a:endParaRPr sz="1900">
+              <a:solidFill>
+                <a:schemeClr val="dk2"/>
+              </a:solidFill>
+              <a:latin typeface="Calibri"/>
+              <a:ea typeface="Calibri"/>
+              <a:cs typeface="Calibri"/>
+              <a:sym typeface="Calibri"/>
+            </a:endParaRPr>
+          </a:p>
+          <a:p>
+            <a:pPr indent="0" lvl="0" marL="0" rtl="0" algn="l">
+              <a:spcBef>
+                <a:spcPts val="0"/>
+              </a:spcBef>
+              <a:spcAft>
+                <a:spcPts val="0"/>
+              </a:spcAft>
+              <a:buNone/>
+            </a:pPr>
+            <a:r>
+              <a:t/>
+            </a:r>
+            <a:endParaRPr sz="1900">
+              <a:solidFill>
+                <a:schemeClr val="dk2"/>
+              </a:solidFill>
+              <a:latin typeface="Calibri"/>
+              <a:ea typeface="Calibri"/>
+              <a:cs typeface="Calibri"/>
+              <a:sym typeface="Calibri"/>
+            </a:endParaRPr>
+          </a:p>
         </p:txBody>
       </p:sp>
       <p:sp>
         <p:nvSpPr>
-          <p:cNvPr id="156" name="Google Shape;156;p23"/>
+          <p:cNvPr id="157" name="Google Shape;157;p23"/>
           <p:cNvSpPr/>
           <p:nvPr/>
         </p:nvSpPr>
@@ -8533,7 +8722,7 @@
       </p:sp>
       <p:sp>
         <p:nvSpPr>
-          <p:cNvPr id="157" name="Google Shape;157;p23"/>
+          <p:cNvPr id="158" name="Google Shape;158;p23"/>
           <p:cNvSpPr txBox="1"/>
           <p:nvPr/>
         </p:nvSpPr>
@@ -8591,7 +8780,7 @@
       </p:sp>
       <p:pic>
         <p:nvPicPr>
-          <p:cNvPr id="158" name="Google Shape;158;p23" title="KMeans_1_centroides.png"/>
+          <p:cNvPr id="159" name="Google Shape;159;p23" title="2.2.3_fig_01_kmeans_jeudis_sept_hps.png"/>
           <p:cNvPicPr preferRelativeResize="0"/>
           <p:nvPr/>
         </p:nvPicPr>
@@ -8605,8 +8794,8 @@
         </p:blipFill>
         <p:spPr>
           <a:xfrm>
-            <a:off x="152400" y="874925"/>
-            <a:ext cx="5366635" cy="3746975"/>
+            <a:off x="0" y="713861"/>
+            <a:ext cx="5822903" cy="4076025"/>
           </a:xfrm>
           <a:prstGeom prst="rect">
             <a:avLst/>
@@ -8637,7 +8826,7 @@
     </p:bg>
     <p:spTree>
       <p:nvGrpSpPr>
-        <p:cNvPr id="162" name="Shape 162"/>
+        <p:cNvPr id="163" name="Shape 163"/>
         <p:cNvGrpSpPr/>
         <p:nvPr/>
       </p:nvGrpSpPr>
@@ -8651,7 +8840,7 @@
       </p:grpSpPr>
       <p:sp>
         <p:nvSpPr>
-          <p:cNvPr id="163" name="Google Shape;163;p24"/>
+          <p:cNvPr id="164" name="Google Shape;164;p24"/>
           <p:cNvSpPr/>
           <p:nvPr/>
         </p:nvSpPr>
@@ -8700,7 +8889,7 @@
       </p:sp>
       <p:sp>
         <p:nvSpPr>
-          <p:cNvPr id="164" name="Google Shape;164;p24"/>
+          <p:cNvPr id="165" name="Google Shape;165;p24"/>
           <p:cNvSpPr txBox="1"/>
           <p:nvPr/>
         </p:nvSpPr>
@@ -8742,19 +8931,7 @@
                 <a:cs typeface="Roboto Light"/>
                 <a:sym typeface="Roboto Light"/>
               </a:rPr>
-              <a:t>Amélioration du modèle</a:t>
-            </a:r>
-            <a:r>
-              <a:rPr lang="fr" sz="2400">
-                <a:solidFill>
-                  <a:schemeClr val="lt1"/>
-                </a:solidFill>
-                <a:latin typeface="Roboto Light"/>
-                <a:ea typeface="Roboto Light"/>
-                <a:cs typeface="Roboto Light"/>
-                <a:sym typeface="Roboto Light"/>
-              </a:rPr>
-              <a:t> : DBScan</a:t>
+              <a:t>Premier modèle KMeans (jeudi sept 2014 HPS 16-19h)</a:t>
             </a:r>
             <a:endParaRPr sz="2400">
               <a:solidFill>
@@ -8770,14 +8947,14 @@
       </p:sp>
       <p:sp>
         <p:nvSpPr>
-          <p:cNvPr id="165" name="Google Shape;165;p24"/>
+          <p:cNvPr id="166" name="Google Shape;166;p24"/>
           <p:cNvSpPr txBox="1"/>
           <p:nvPr/>
         </p:nvSpPr>
         <p:spPr>
           <a:xfrm>
-            <a:off x="5923475" y="882725"/>
-            <a:ext cx="3126600" cy="3745800"/>
+            <a:off x="5877250" y="874926"/>
+            <a:ext cx="3194100" cy="3621000"/>
           </a:xfrm>
           <a:prstGeom prst="rect">
             <a:avLst/>
@@ -8793,7 +8970,7 @@
           </a:bodyPr>
           <a:lstStyle/>
           <a:p>
-            <a:pPr indent="-342900" lvl="0" marL="457200" rtl="0" algn="l">
+            <a:pPr indent="-349250" lvl="0" marL="457200" rtl="0" algn="l">
               <a:spcBef>
                 <a:spcPts val="0"/>
               </a:spcBef>
@@ -8803,12 +8980,12 @@
               <a:buClr>
                 <a:schemeClr val="dk2"/>
               </a:buClr>
-              <a:buSzPts val="1800"/>
+              <a:buSzPts val="1900"/>
               <a:buFont typeface="Calibri"/>
               <a:buChar char="●"/>
             </a:pPr>
             <a:r>
-              <a:rPr lang="fr" sz="1800">
+              <a:rPr lang="fr" sz="1900">
                 <a:solidFill>
                   <a:schemeClr val="dk2"/>
                 </a:solidFill>
@@ -8817,10 +8994,10 @@
                 <a:cs typeface="Calibri"/>
                 <a:sym typeface="Calibri"/>
               </a:rPr>
-              <a:t>trouve de lui-</a:t>
-            </a:r>
-            <a:r>
-              <a:rPr lang="fr" sz="1800">
+              <a:t>affichage des </a:t>
+            </a:r>
+            <a:r>
+              <a:rPr lang="fr" sz="1900">
                 <a:solidFill>
                   <a:schemeClr val="dk2"/>
                 </a:solidFill>
@@ -8829,10 +9006,10 @@
                 <a:cs typeface="Calibri"/>
                 <a:sym typeface="Calibri"/>
               </a:rPr>
-              <a:t>même</a:t>
-            </a:r>
-            <a:r>
-              <a:rPr lang="fr" sz="1800">
+              <a:t>centroïdes</a:t>
+            </a:r>
+            <a:r>
+              <a:rPr lang="fr" sz="1900">
                 <a:solidFill>
                   <a:schemeClr val="dk2"/>
                 </a:solidFill>
@@ -8841,9 +9018,9 @@
                 <a:cs typeface="Calibri"/>
                 <a:sym typeface="Calibri"/>
               </a:rPr>
-              <a:t> les clusters</a:t>
-            </a:r>
-            <a:endParaRPr sz="1800">
+              <a:t> avec leurs poids respectifs</a:t>
+            </a:r>
+            <a:endParaRPr sz="1900">
               <a:solidFill>
                 <a:schemeClr val="dk2"/>
               </a:solidFill>
@@ -8854,7 +9031,7 @@
             </a:endParaRPr>
           </a:p>
           <a:p>
-            <a:pPr indent="-342900" lvl="0" marL="457200" rtl="0" algn="l">
+            <a:pPr indent="-349250" lvl="0" marL="457200" rtl="0" algn="l">
               <a:spcBef>
                 <a:spcPts val="0"/>
               </a:spcBef>
@@ -8864,12 +9041,12 @@
               <a:buClr>
                 <a:schemeClr val="dk2"/>
               </a:buClr>
-              <a:buSzPts val="1800"/>
+              <a:buSzPts val="1900"/>
               <a:buFont typeface="Calibri"/>
               <a:buChar char="●"/>
             </a:pPr>
             <a:r>
-              <a:rPr lang="fr" sz="1800">
+              <a:rPr lang="fr" sz="1900">
                 <a:solidFill>
                   <a:schemeClr val="dk2"/>
                 </a:solidFill>
@@ -8878,9 +9055,9 @@
                 <a:cs typeface="Calibri"/>
                 <a:sym typeface="Calibri"/>
               </a:rPr>
-              <a:t>élimine les outliers automatiquement</a:t>
-            </a:r>
-            <a:endParaRPr sz="1800">
+              <a:t>permet meilleure visu des hot-zones</a:t>
+            </a:r>
+            <a:endParaRPr sz="1900">
               <a:solidFill>
                 <a:schemeClr val="dk2"/>
               </a:solidFill>
@@ -8901,9 +9078,18 @@
               <a:buNone/>
             </a:pPr>
             <a:r>
-              <a:t/>
-            </a:r>
-            <a:endParaRPr sz="1800">
+              <a:rPr lang="fr" sz="1900">
+                <a:solidFill>
+                  <a:schemeClr val="dk2"/>
+                </a:solidFill>
+                <a:latin typeface="Calibri"/>
+                <a:ea typeface="Calibri"/>
+                <a:cs typeface="Calibri"/>
+                <a:sym typeface="Calibri"/>
+              </a:rPr>
+              <a:t>mais…</a:t>
+            </a:r>
+            <a:endParaRPr sz="1900">
               <a:solidFill>
                 <a:schemeClr val="dk2"/>
               </a:solidFill>
@@ -8914,17 +9100,22 @@
             </a:endParaRPr>
           </a:p>
           <a:p>
-            <a:pPr indent="0" lvl="0" marL="0" rtl="0" algn="l">
-              <a:spcBef>
-                <a:spcPts val="0"/>
-              </a:spcBef>
-              <a:spcAft>
-                <a:spcPts val="0"/>
-              </a:spcAft>
-              <a:buNone/>
-            </a:pPr>
-            <a:r>
-              <a:rPr lang="fr" sz="1800">
+            <a:pPr indent="-349250" lvl="0" marL="457200" rtl="0" algn="l">
+              <a:spcBef>
+                <a:spcPts val="0"/>
+              </a:spcBef>
+              <a:spcAft>
+                <a:spcPts val="0"/>
+              </a:spcAft>
+              <a:buClr>
+                <a:schemeClr val="dk2"/>
+              </a:buClr>
+              <a:buSzPts val="1900"/>
+              <a:buFont typeface="Calibri"/>
+              <a:buChar char="●"/>
+            </a:pPr>
+            <a:r>
+              <a:rPr lang="fr" sz="1900">
                 <a:solidFill>
                   <a:schemeClr val="dk2"/>
                 </a:solidFill>
@@ -8933,9 +9124,9 @@
                 <a:cs typeface="Calibri"/>
                 <a:sym typeface="Calibri"/>
               </a:rPr>
-              <a:t>mais…</a:t>
-            </a:r>
-            <a:endParaRPr sz="1800">
+              <a:t>serait préférable d’ajouter polygones des hot-zones</a:t>
+            </a:r>
+            <a:endParaRPr sz="1900">
               <a:solidFill>
                 <a:schemeClr val="dk2"/>
               </a:solidFill>
@@ -8946,7 +9137,7 @@
             </a:endParaRPr>
           </a:p>
           <a:p>
-            <a:pPr indent="-342900" lvl="0" marL="457200" rtl="0" algn="l">
+            <a:pPr indent="-349250" lvl="0" marL="457200" rtl="0" algn="l">
               <a:spcBef>
                 <a:spcPts val="0"/>
               </a:spcBef>
@@ -8956,12 +9147,12 @@
               <a:buClr>
                 <a:schemeClr val="dk2"/>
               </a:buClr>
-              <a:buSzPts val="1800"/>
+              <a:buSzPts val="1900"/>
               <a:buFont typeface="Calibri"/>
               <a:buChar char="●"/>
             </a:pPr>
             <a:r>
-              <a:rPr lang="fr" sz="1800">
+              <a:rPr lang="fr" sz="1900">
                 <a:solidFill>
                   <a:schemeClr val="dk2"/>
                 </a:solidFill>
@@ -8970,9 +9161,9 @@
                 <a:cs typeface="Calibri"/>
                 <a:sym typeface="Calibri"/>
               </a:rPr>
-              <a:t>EPS_M=200m</a:t>
-            </a:r>
-            <a:endParaRPr sz="1800">
+              <a:t>+ la densité des courses/m2</a:t>
+            </a:r>
+            <a:endParaRPr sz="1900">
               <a:solidFill>
                 <a:schemeClr val="dk2"/>
               </a:solidFill>
@@ -8983,7 +9174,7 @@
             </a:endParaRPr>
           </a:p>
           <a:p>
-            <a:pPr indent="-342900" lvl="0" marL="457200" rtl="0" algn="l">
+            <a:pPr indent="-349250" lvl="0" marL="457200" rtl="0" algn="l">
               <a:spcBef>
                 <a:spcPts val="0"/>
               </a:spcBef>
@@ -8993,12 +9184,12 @@
               <a:buClr>
                 <a:schemeClr val="dk2"/>
               </a:buClr>
-              <a:buSzPts val="1800"/>
+              <a:buSzPts val="1900"/>
               <a:buFont typeface="Calibri"/>
               <a:buChar char="●"/>
             </a:pPr>
             <a:r>
-              <a:rPr lang="fr" sz="1800">
+              <a:rPr lang="fr" sz="1900">
                 <a:solidFill>
                   <a:schemeClr val="dk2"/>
                 </a:solidFill>
@@ -9007,9 +9198,33 @@
                 <a:cs typeface="Calibri"/>
                 <a:sym typeface="Calibri"/>
               </a:rPr>
-              <a:t>MIN_SAMPLES=50</a:t>
-            </a:r>
-            <a:endParaRPr sz="1800">
+              <a:t>adaptation taille </a:t>
+            </a:r>
+            <a:r>
+              <a:rPr lang="fr" sz="1900">
+                <a:solidFill>
+                  <a:schemeClr val="dk2"/>
+                </a:solidFill>
+                <a:latin typeface="Calibri"/>
+                <a:ea typeface="Calibri"/>
+                <a:cs typeface="Calibri"/>
+                <a:sym typeface="Calibri"/>
+              </a:rPr>
+              <a:t>centroïdes</a:t>
+            </a:r>
+            <a:r>
+              <a:rPr lang="fr" sz="1900">
+                <a:solidFill>
+                  <a:schemeClr val="dk2"/>
+                </a:solidFill>
+                <a:latin typeface="Calibri"/>
+                <a:ea typeface="Calibri"/>
+                <a:cs typeface="Calibri"/>
+                <a:sym typeface="Calibri"/>
+              </a:rPr>
+              <a:t> / zoom</a:t>
+            </a:r>
+            <a:endParaRPr sz="1900">
               <a:solidFill>
                 <a:schemeClr val="dk2"/>
               </a:solidFill>
@@ -9019,60 +9234,11 @@
               <a:sym typeface="Calibri"/>
             </a:endParaRPr>
           </a:p>
-          <a:p>
-            <a:pPr indent="-342900" lvl="0" marL="457200" rtl="0" algn="l">
-              <a:spcBef>
-                <a:spcPts val="0"/>
-              </a:spcBef>
-              <a:spcAft>
-                <a:spcPts val="0"/>
-              </a:spcAft>
-              <a:buClr>
-                <a:schemeClr val="dk2"/>
-              </a:buClr>
-              <a:buSzPts val="1800"/>
-              <a:buFont typeface="Calibri"/>
-              <a:buChar char="●"/>
-            </a:pPr>
-            <a:r>
-              <a:rPr lang="fr" sz="1800">
-                <a:solidFill>
-                  <a:schemeClr val="dk2"/>
-                </a:solidFill>
-                <a:latin typeface="Calibri"/>
-                <a:ea typeface="Calibri"/>
-                <a:cs typeface="Calibri"/>
-                <a:sym typeface="Calibri"/>
-              </a:rPr>
-              <a:t>paramétrage </a:t>
-            </a:r>
-            <a:r>
-              <a:rPr lang="fr" sz="1800">
-                <a:solidFill>
-                  <a:schemeClr val="dk2"/>
-                </a:solidFill>
-                <a:latin typeface="Calibri"/>
-                <a:ea typeface="Calibri"/>
-                <a:cs typeface="Calibri"/>
-                <a:sym typeface="Calibri"/>
-              </a:rPr>
-              <a:t>très sensible pour obtenir un rendu correct</a:t>
-            </a:r>
-            <a:endParaRPr sz="1800">
-              <a:solidFill>
-                <a:schemeClr val="dk2"/>
-              </a:solidFill>
-              <a:latin typeface="Calibri"/>
-              <a:ea typeface="Calibri"/>
-              <a:cs typeface="Calibri"/>
-              <a:sym typeface="Calibri"/>
-            </a:endParaRPr>
-          </a:p>
         </p:txBody>
       </p:sp>
       <p:sp>
         <p:nvSpPr>
-          <p:cNvPr id="166" name="Google Shape;166;p24"/>
+          <p:cNvPr id="167" name="Google Shape;167;p24"/>
           <p:cNvSpPr/>
           <p:nvPr/>
         </p:nvSpPr>
@@ -9121,7 +9287,7 @@
       </p:sp>
       <p:sp>
         <p:nvSpPr>
-          <p:cNvPr id="167" name="Google Shape;167;p24"/>
+          <p:cNvPr id="168" name="Google Shape;168;p24"/>
           <p:cNvSpPr txBox="1"/>
           <p:nvPr/>
         </p:nvSpPr>
@@ -9179,7 +9345,7 @@
       </p:sp>
       <p:pic>
         <p:nvPicPr>
-          <p:cNvPr id="168" name="Google Shape;168;p24"/>
+          <p:cNvPr id="169" name="Google Shape;169;p24" title="KMeans_1_centroides.png"/>
           <p:cNvPicPr preferRelativeResize="0"/>
           <p:nvPr/>
         </p:nvPicPr>
@@ -9193,8 +9359,8 @@
         </p:blipFill>
         <p:spPr>
           <a:xfrm>
-            <a:off x="0" y="757200"/>
-            <a:ext cx="5728717" cy="3966024"/>
+            <a:off x="152400" y="874925"/>
+            <a:ext cx="5366635" cy="3746975"/>
           </a:xfrm>
           <a:prstGeom prst="rect">
             <a:avLst/>
@@ -9225,7 +9391,7 @@
     </p:bg>
     <p:spTree>
       <p:nvGrpSpPr>
-        <p:cNvPr id="172" name="Shape 172"/>
+        <p:cNvPr id="173" name="Shape 173"/>
         <p:cNvGrpSpPr/>
         <p:nvPr/>
       </p:nvGrpSpPr>
@@ -9239,7 +9405,7 @@
       </p:grpSpPr>
       <p:sp>
         <p:nvSpPr>
-          <p:cNvPr id="173" name="Google Shape;173;p25"/>
+          <p:cNvPr id="174" name="Google Shape;174;p25"/>
           <p:cNvSpPr/>
           <p:nvPr/>
         </p:nvSpPr>
@@ -9288,7 +9454,7 @@
       </p:sp>
       <p:sp>
         <p:nvSpPr>
-          <p:cNvPr id="174" name="Google Shape;174;p25"/>
+          <p:cNvPr id="175" name="Google Shape;175;p25"/>
           <p:cNvSpPr txBox="1"/>
           <p:nvPr/>
         </p:nvSpPr>
@@ -9318,11 +9484,6 @@
               <a:spcAft>
                 <a:spcPts val="0"/>
               </a:spcAft>
-              <a:buClr>
-                <a:schemeClr val="dk1"/>
-              </a:buClr>
-              <a:buSzPts val="1100"/>
-              <a:buFont typeface="Arial"/>
               <a:buNone/>
             </a:pPr>
             <a:r>
@@ -9335,7 +9496,19 @@
                 <a:cs typeface="Roboto Light"/>
                 <a:sym typeface="Roboto Light"/>
               </a:rPr>
-              <a:t>Amélioration du modèle : HDBScan</a:t>
+              <a:t>Amélioration du modèle</a:t>
+            </a:r>
+            <a:r>
+              <a:rPr lang="fr" sz="2400">
+                <a:solidFill>
+                  <a:schemeClr val="lt1"/>
+                </a:solidFill>
+                <a:latin typeface="Roboto Light"/>
+                <a:ea typeface="Roboto Light"/>
+                <a:cs typeface="Roboto Light"/>
+                <a:sym typeface="Roboto Light"/>
+              </a:rPr>
+              <a:t> : DBScan</a:t>
             </a:r>
             <a:endParaRPr sz="2400">
               <a:solidFill>
@@ -9347,41 +9520,18 @@
               <a:sym typeface="Roboto Light"/>
             </a:endParaRPr>
           </a:p>
-          <a:p>
-            <a:pPr indent="0" lvl="0" marL="0" rtl="0" algn="l">
-              <a:spcBef>
-                <a:spcPts val="0"/>
-              </a:spcBef>
-              <a:spcAft>
-                <a:spcPts val="0"/>
-              </a:spcAft>
-              <a:buNone/>
-            </a:pPr>
-            <a:r>
-              <a:t/>
-            </a:r>
-            <a:endParaRPr sz="2400">
-              <a:solidFill>
-                <a:schemeClr val="lt1"/>
-              </a:solidFill>
-              <a:latin typeface="Roboto Light"/>
-              <a:ea typeface="Roboto Light"/>
-              <a:cs typeface="Roboto Light"/>
-              <a:sym typeface="Roboto Light"/>
-            </a:endParaRPr>
-          </a:p>
         </p:txBody>
       </p:sp>
       <p:sp>
         <p:nvSpPr>
-          <p:cNvPr id="175" name="Google Shape;175;p25"/>
+          <p:cNvPr id="176" name="Google Shape;176;p25"/>
           <p:cNvSpPr txBox="1"/>
           <p:nvPr/>
         </p:nvSpPr>
         <p:spPr>
           <a:xfrm>
-            <a:off x="5688025" y="947750"/>
-            <a:ext cx="3321000" cy="3598800"/>
+            <a:off x="5923475" y="882725"/>
+            <a:ext cx="3126600" cy="3745800"/>
           </a:xfrm>
           <a:prstGeom prst="rect">
             <a:avLst/>
@@ -9421,7 +9571,7 @@
                 <a:cs typeface="Calibri"/>
                 <a:sym typeface="Calibri"/>
               </a:rPr>
-              <a:t>EPS_M </a:t>
+              <a:t>trouve de lui-</a:t>
             </a:r>
             <a:r>
               <a:rPr lang="fr" sz="1800">
@@ -9433,7 +9583,19 @@
                 <a:cs typeface="Calibri"/>
                 <a:sym typeface="Calibri"/>
               </a:rPr>
-              <a:t>varie automatiquement donc trouve mieux les densités différentes</a:t>
+              <a:t>même</a:t>
+            </a:r>
+            <a:r>
+              <a:rPr lang="fr" sz="1800">
+                <a:solidFill>
+                  <a:schemeClr val="dk2"/>
+                </a:solidFill>
+                <a:latin typeface="Calibri"/>
+                <a:ea typeface="Calibri"/>
+                <a:cs typeface="Calibri"/>
+                <a:sym typeface="Calibri"/>
+              </a:rPr>
+              <a:t> les clusters</a:t>
             </a:r>
             <a:endParaRPr sz="1800">
               <a:solidFill>
@@ -9470,7 +9632,7 @@
                 <a:cs typeface="Calibri"/>
                 <a:sym typeface="Calibri"/>
               </a:rPr>
-              <a:t>méthode “leaf” : clusters plus granulaires moins stables moins gros</a:t>
+              <a:t>élimine les outliers automatiquement</a:t>
             </a:r>
             <a:endParaRPr sz="1800">
               <a:solidFill>
@@ -9482,11 +9644,189 @@
               <a:sym typeface="Calibri"/>
             </a:endParaRPr>
           </a:p>
+          <a:p>
+            <a:pPr indent="0" lvl="0" marL="0" rtl="0" algn="l">
+              <a:spcBef>
+                <a:spcPts val="0"/>
+              </a:spcBef>
+              <a:spcAft>
+                <a:spcPts val="0"/>
+              </a:spcAft>
+              <a:buNone/>
+            </a:pPr>
+            <a:r>
+              <a:t/>
+            </a:r>
+            <a:endParaRPr sz="1800">
+              <a:solidFill>
+                <a:schemeClr val="dk2"/>
+              </a:solidFill>
+              <a:latin typeface="Calibri"/>
+              <a:ea typeface="Calibri"/>
+              <a:cs typeface="Calibri"/>
+              <a:sym typeface="Calibri"/>
+            </a:endParaRPr>
+          </a:p>
+          <a:p>
+            <a:pPr indent="0" lvl="0" marL="0" rtl="0" algn="l">
+              <a:spcBef>
+                <a:spcPts val="0"/>
+              </a:spcBef>
+              <a:spcAft>
+                <a:spcPts val="0"/>
+              </a:spcAft>
+              <a:buNone/>
+            </a:pPr>
+            <a:r>
+              <a:rPr lang="fr" sz="1800">
+                <a:solidFill>
+                  <a:schemeClr val="dk2"/>
+                </a:solidFill>
+                <a:latin typeface="Calibri"/>
+                <a:ea typeface="Calibri"/>
+                <a:cs typeface="Calibri"/>
+                <a:sym typeface="Calibri"/>
+              </a:rPr>
+              <a:t>mais…</a:t>
+            </a:r>
+            <a:endParaRPr sz="1800">
+              <a:solidFill>
+                <a:schemeClr val="dk2"/>
+              </a:solidFill>
+              <a:latin typeface="Calibri"/>
+              <a:ea typeface="Calibri"/>
+              <a:cs typeface="Calibri"/>
+              <a:sym typeface="Calibri"/>
+            </a:endParaRPr>
+          </a:p>
+          <a:p>
+            <a:pPr indent="-342900" lvl="0" marL="457200" rtl="0" algn="l">
+              <a:spcBef>
+                <a:spcPts val="0"/>
+              </a:spcBef>
+              <a:spcAft>
+                <a:spcPts val="0"/>
+              </a:spcAft>
+              <a:buClr>
+                <a:schemeClr val="dk2"/>
+              </a:buClr>
+              <a:buSzPts val="1800"/>
+              <a:buFont typeface="Calibri"/>
+              <a:buChar char="●"/>
+            </a:pPr>
+            <a:r>
+              <a:rPr lang="fr" sz="1800">
+                <a:solidFill>
+                  <a:schemeClr val="dk2"/>
+                </a:solidFill>
+                <a:latin typeface="Calibri"/>
+                <a:ea typeface="Calibri"/>
+                <a:cs typeface="Calibri"/>
+                <a:sym typeface="Calibri"/>
+              </a:rPr>
+              <a:t>EPS_M=200m</a:t>
+            </a:r>
+            <a:endParaRPr sz="1800">
+              <a:solidFill>
+                <a:schemeClr val="dk2"/>
+              </a:solidFill>
+              <a:latin typeface="Calibri"/>
+              <a:ea typeface="Calibri"/>
+              <a:cs typeface="Calibri"/>
+              <a:sym typeface="Calibri"/>
+            </a:endParaRPr>
+          </a:p>
+          <a:p>
+            <a:pPr indent="-342900" lvl="0" marL="457200" rtl="0" algn="l">
+              <a:spcBef>
+                <a:spcPts val="0"/>
+              </a:spcBef>
+              <a:spcAft>
+                <a:spcPts val="0"/>
+              </a:spcAft>
+              <a:buClr>
+                <a:schemeClr val="dk2"/>
+              </a:buClr>
+              <a:buSzPts val="1800"/>
+              <a:buFont typeface="Calibri"/>
+              <a:buChar char="●"/>
+            </a:pPr>
+            <a:r>
+              <a:rPr lang="fr" sz="1800">
+                <a:solidFill>
+                  <a:schemeClr val="dk2"/>
+                </a:solidFill>
+                <a:latin typeface="Calibri"/>
+                <a:ea typeface="Calibri"/>
+                <a:cs typeface="Calibri"/>
+                <a:sym typeface="Calibri"/>
+              </a:rPr>
+              <a:t>MIN_SAMPLES=50</a:t>
+            </a:r>
+            <a:endParaRPr sz="1800">
+              <a:solidFill>
+                <a:schemeClr val="dk2"/>
+              </a:solidFill>
+              <a:latin typeface="Calibri"/>
+              <a:ea typeface="Calibri"/>
+              <a:cs typeface="Calibri"/>
+              <a:sym typeface="Calibri"/>
+            </a:endParaRPr>
+          </a:p>
+          <a:p>
+            <a:pPr indent="-342900" lvl="0" marL="457200" rtl="0" algn="l">
+              <a:spcBef>
+                <a:spcPts val="0"/>
+              </a:spcBef>
+              <a:spcAft>
+                <a:spcPts val="0"/>
+              </a:spcAft>
+              <a:buClr>
+                <a:schemeClr val="dk2"/>
+              </a:buClr>
+              <a:buSzPts val="1800"/>
+              <a:buFont typeface="Calibri"/>
+              <a:buChar char="●"/>
+            </a:pPr>
+            <a:r>
+              <a:rPr lang="fr" sz="1800">
+                <a:solidFill>
+                  <a:schemeClr val="dk2"/>
+                </a:solidFill>
+                <a:latin typeface="Calibri"/>
+                <a:ea typeface="Calibri"/>
+                <a:cs typeface="Calibri"/>
+                <a:sym typeface="Calibri"/>
+              </a:rPr>
+              <a:t>paramétrage </a:t>
+            </a:r>
+            <a:r>
+              <a:rPr lang="fr" sz="1800">
+                <a:solidFill>
+                  <a:schemeClr val="dk2"/>
+                </a:solidFill>
+                <a:latin typeface="Calibri"/>
+                <a:ea typeface="Calibri"/>
+                <a:cs typeface="Calibri"/>
+                <a:sym typeface="Calibri"/>
+              </a:rPr>
+              <a:t>très sensible pour obtenir un rendu correct</a:t>
+            </a:r>
+            <a:endParaRPr sz="1800">
+              <a:solidFill>
+                <a:schemeClr val="dk2"/>
+              </a:solidFill>
+              <a:latin typeface="Calibri"/>
+              <a:ea typeface="Calibri"/>
+              <a:cs typeface="Calibri"/>
+              <a:sym typeface="Calibri"/>
+            </a:endParaRPr>
+          </a:p>
         </p:txBody>
       </p:sp>
       <p:sp>
         <p:nvSpPr>
-          <p:cNvPr id="176" name="Google Shape;176;p25"/>
+          <p:cNvPr id="177" name="Google Shape;177;p25"/>
           <p:cNvSpPr/>
           <p:nvPr/>
         </p:nvSpPr>
@@ -9535,7 +9875,7 @@
       </p:sp>
       <p:sp>
         <p:nvSpPr>
-          <p:cNvPr id="177" name="Google Shape;177;p25"/>
+          <p:cNvPr id="178" name="Google Shape;178;p25"/>
           <p:cNvSpPr txBox="1"/>
           <p:nvPr/>
         </p:nvSpPr>
@@ -9593,7 +9933,7 @@
       </p:sp>
       <p:pic>
         <p:nvPicPr>
-          <p:cNvPr id="178" name="Google Shape;178;p25"/>
+          <p:cNvPr id="179" name="Google Shape;179;p25"/>
           <p:cNvPicPr preferRelativeResize="0"/>
           <p:nvPr/>
         </p:nvPicPr>
@@ -9607,8 +9947,8 @@
         </p:blipFill>
         <p:spPr>
           <a:xfrm>
-            <a:off x="40375" y="794700"/>
-            <a:ext cx="5466776" cy="3914725"/>
+            <a:off x="0" y="757200"/>
+            <a:ext cx="5728717" cy="3966024"/>
           </a:xfrm>
           <a:prstGeom prst="rect">
             <a:avLst/>
@@ -9639,7 +9979,7 @@
     </p:bg>
     <p:spTree>
       <p:nvGrpSpPr>
-        <p:cNvPr id="182" name="Shape 182"/>
+        <p:cNvPr id="183" name="Shape 183"/>
         <p:cNvGrpSpPr/>
         <p:nvPr/>
       </p:nvGrpSpPr>
@@ -9653,7 +9993,7 @@
       </p:grpSpPr>
       <p:sp>
         <p:nvSpPr>
-          <p:cNvPr id="183" name="Google Shape;183;p26"/>
+          <p:cNvPr id="184" name="Google Shape;184;p26"/>
           <p:cNvSpPr/>
           <p:nvPr/>
         </p:nvSpPr>
@@ -9702,7 +10042,7 @@
       </p:sp>
       <p:sp>
         <p:nvSpPr>
-          <p:cNvPr id="184" name="Google Shape;184;p26"/>
+          <p:cNvPr id="185" name="Google Shape;185;p26"/>
           <p:cNvSpPr txBox="1"/>
           <p:nvPr/>
         </p:nvSpPr>
@@ -9732,6 +10072,11 @@
               <a:spcAft>
                 <a:spcPts val="0"/>
               </a:spcAft>
+              <a:buClr>
+                <a:schemeClr val="dk1"/>
+              </a:buClr>
+              <a:buSzPts val="1100"/>
+              <a:buFont typeface="Arial"/>
               <a:buNone/>
             </a:pPr>
             <a:r>
@@ -9744,7 +10089,7 @@
                 <a:cs typeface="Roboto Light"/>
                 <a:sym typeface="Roboto Light"/>
               </a:rPr>
-              <a:t>Amélioration du modèle : H3 bining hexagonal</a:t>
+              <a:t>Amélioration du modèle : HDBScan</a:t>
             </a:r>
             <a:endParaRPr sz="2400">
               <a:solidFill>
@@ -9783,14 +10128,14 @@
       </p:sp>
       <p:sp>
         <p:nvSpPr>
-          <p:cNvPr id="185" name="Google Shape;185;p26"/>
+          <p:cNvPr id="186" name="Google Shape;186;p26"/>
           <p:cNvSpPr txBox="1"/>
           <p:nvPr/>
         </p:nvSpPr>
         <p:spPr>
           <a:xfrm>
-            <a:off x="6029475" y="947750"/>
-            <a:ext cx="2958600" cy="3598800"/>
+            <a:off x="5688025" y="947750"/>
+            <a:ext cx="3321000" cy="3598800"/>
           </a:xfrm>
           <a:prstGeom prst="rect">
             <a:avLst/>
@@ -9830,7 +10175,19 @@
                 <a:cs typeface="Calibri"/>
                 <a:sym typeface="Calibri"/>
               </a:rPr>
-              <a:t>simple</a:t>
+              <a:t>EPS_M </a:t>
+            </a:r>
+            <a:r>
+              <a:rPr lang="fr" sz="1800">
+                <a:solidFill>
+                  <a:schemeClr val="dk2"/>
+                </a:solidFill>
+                <a:latin typeface="Calibri"/>
+                <a:ea typeface="Calibri"/>
+                <a:cs typeface="Calibri"/>
+                <a:sym typeface="Calibri"/>
+              </a:rPr>
+              <a:t>varie automatiquement donc trouve mieux les densités différentes</a:t>
             </a:r>
             <a:endParaRPr sz="1800">
               <a:solidFill>
@@ -9867,31 +10224,7 @@
                 <a:cs typeface="Calibri"/>
                 <a:sym typeface="Calibri"/>
               </a:rPr>
-              <a:t>pas </a:t>
-            </a:r>
-            <a:r>
-              <a:rPr lang="fr" sz="1800">
-                <a:solidFill>
-                  <a:schemeClr val="dk2"/>
-                </a:solidFill>
-                <a:latin typeface="Calibri"/>
-                <a:ea typeface="Calibri"/>
-                <a:cs typeface="Calibri"/>
-                <a:sym typeface="Calibri"/>
-              </a:rPr>
-              <a:t>d’hyperparamètre</a:t>
-            </a:r>
-            <a:r>
-              <a:rPr lang="fr" sz="1800">
-                <a:solidFill>
-                  <a:schemeClr val="dk2"/>
-                </a:solidFill>
-                <a:latin typeface="Calibri"/>
-                <a:ea typeface="Calibri"/>
-                <a:cs typeface="Calibri"/>
-                <a:sym typeface="Calibri"/>
-              </a:rPr>
-              <a:t>! hormis la taille de l’hexagone</a:t>
+              <a:t>méthode “leaf” : clusters </a:t>
             </a:r>
             <a:endParaRPr sz="1800">
               <a:solidFill>
@@ -9904,7 +10237,7 @@
             </a:endParaRPr>
           </a:p>
           <a:p>
-            <a:pPr indent="-342900" lvl="0" marL="457200" rtl="0" algn="l">
+            <a:pPr indent="-342900" lvl="1" marL="914400" rtl="0" algn="l">
               <a:spcBef>
                 <a:spcPts val="0"/>
               </a:spcBef>
@@ -9916,7 +10249,7 @@
               </a:buClr>
               <a:buSzPts val="1800"/>
               <a:buFont typeface="Calibri"/>
-              <a:buChar char="●"/>
+              <a:buChar char="○"/>
             </a:pPr>
             <a:r>
               <a:rPr lang="fr" sz="1800">
@@ -9928,7 +10261,7 @@
                 <a:cs typeface="Calibri"/>
                 <a:sym typeface="Calibri"/>
               </a:rPr>
-              <a:t>calcul de la densité immédiat</a:t>
+              <a:t>plus granulaires</a:t>
             </a:r>
             <a:endParaRPr sz="1800">
               <a:solidFill>
@@ -9941,7 +10274,7 @@
             </a:endParaRPr>
           </a:p>
           <a:p>
-            <a:pPr indent="-342900" lvl="0" marL="457200" rtl="0" algn="l">
+            <a:pPr indent="-342900" lvl="1" marL="914400" rtl="0" algn="l">
               <a:spcBef>
                 <a:spcPts val="0"/>
               </a:spcBef>
@@ -9953,7 +10286,7 @@
               </a:buClr>
               <a:buSzPts val="1800"/>
               <a:buFont typeface="Calibri"/>
-              <a:buChar char="●"/>
+              <a:buChar char="○"/>
             </a:pPr>
             <a:r>
               <a:rPr lang="fr" sz="1800">
@@ -9965,7 +10298,7 @@
                 <a:cs typeface="Calibri"/>
                 <a:sym typeface="Calibri"/>
               </a:rPr>
-              <a:t>visu plus précise des spots très denses</a:t>
+              <a:t>moins stables</a:t>
             </a:r>
             <a:endParaRPr sz="1800">
               <a:solidFill>
@@ -9978,17 +10311,31 @@
             </a:endParaRPr>
           </a:p>
           <a:p>
-            <a:pPr indent="0" lvl="0" marL="0" rtl="0" algn="l">
-              <a:spcBef>
-                <a:spcPts val="0"/>
-              </a:spcBef>
-              <a:spcAft>
-                <a:spcPts val="0"/>
-              </a:spcAft>
-              <a:buNone/>
-            </a:pPr>
-            <a:r>
-              <a:t/>
+            <a:pPr indent="-342900" lvl="1" marL="914400" rtl="0" algn="l">
+              <a:spcBef>
+                <a:spcPts val="0"/>
+              </a:spcBef>
+              <a:spcAft>
+                <a:spcPts val="0"/>
+              </a:spcAft>
+              <a:buClr>
+                <a:schemeClr val="dk2"/>
+              </a:buClr>
+              <a:buSzPts val="1800"/>
+              <a:buFont typeface="Calibri"/>
+              <a:buChar char="○"/>
+            </a:pPr>
+            <a:r>
+              <a:rPr lang="fr" sz="1800">
+                <a:solidFill>
+                  <a:schemeClr val="dk2"/>
+                </a:solidFill>
+                <a:latin typeface="Calibri"/>
+                <a:ea typeface="Calibri"/>
+                <a:cs typeface="Calibri"/>
+                <a:sym typeface="Calibri"/>
+              </a:rPr>
+              <a:t>moins gros</a:t>
             </a:r>
             <a:endParaRPr sz="1800">
               <a:solidFill>
@@ -10004,7 +10351,7 @@
       </p:sp>
       <p:sp>
         <p:nvSpPr>
-          <p:cNvPr id="186" name="Google Shape;186;p26"/>
+          <p:cNvPr id="187" name="Google Shape;187;p26"/>
           <p:cNvSpPr/>
           <p:nvPr/>
         </p:nvSpPr>
@@ -10053,7 +10400,7 @@
       </p:sp>
       <p:sp>
         <p:nvSpPr>
-          <p:cNvPr id="187" name="Google Shape;187;p26"/>
+          <p:cNvPr id="188" name="Google Shape;188;p26"/>
           <p:cNvSpPr txBox="1"/>
           <p:nvPr/>
         </p:nvSpPr>
@@ -10111,7 +10458,7 @@
       </p:sp>
       <p:pic>
         <p:nvPicPr>
-          <p:cNvPr id="188" name="Google Shape;188;p26"/>
+          <p:cNvPr id="189" name="Google Shape;189;p26"/>
           <p:cNvPicPr preferRelativeResize="0"/>
           <p:nvPr/>
         </p:nvPicPr>
@@ -10125,8 +10472,8 @@
         </p:blipFill>
         <p:spPr>
           <a:xfrm>
-            <a:off x="152400" y="874925"/>
-            <a:ext cx="5529140" cy="3746975"/>
+            <a:off x="40375" y="794700"/>
+            <a:ext cx="5466776" cy="3914725"/>
           </a:xfrm>
           <a:prstGeom prst="rect">
             <a:avLst/>
@@ -10157,7 +10504,7 @@
     </p:bg>
     <p:spTree>
       <p:nvGrpSpPr>
-        <p:cNvPr id="192" name="Shape 192"/>
+        <p:cNvPr id="193" name="Shape 193"/>
         <p:cNvGrpSpPr/>
         <p:nvPr/>
       </p:nvGrpSpPr>
@@ -10171,7 +10518,7 @@
       </p:grpSpPr>
       <p:sp>
         <p:nvSpPr>
-          <p:cNvPr id="193" name="Google Shape;193;p27"/>
+          <p:cNvPr id="194" name="Google Shape;194;p27"/>
           <p:cNvSpPr/>
           <p:nvPr/>
         </p:nvSpPr>
@@ -10220,7 +10567,7 @@
       </p:sp>
       <p:sp>
         <p:nvSpPr>
-          <p:cNvPr id="194" name="Google Shape;194;p27"/>
+          <p:cNvPr id="195" name="Google Shape;195;p27"/>
           <p:cNvSpPr txBox="1"/>
           <p:nvPr/>
         </p:nvSpPr>
@@ -10262,7 +10609,7 @@
                 <a:cs typeface="Roboto Light"/>
                 <a:sym typeface="Roboto Light"/>
               </a:rPr>
-              <a:t>Généralisation</a:t>
+              <a:t>Amélioration du modèle : H3 bining hexagonal</a:t>
             </a:r>
             <a:endParaRPr sz="2400">
               <a:solidFill>
@@ -10274,18 +10621,41 @@
               <a:sym typeface="Roboto Light"/>
             </a:endParaRPr>
           </a:p>
+          <a:p>
+            <a:pPr indent="0" lvl="0" marL="0" rtl="0" algn="l">
+              <a:spcBef>
+                <a:spcPts val="0"/>
+              </a:spcBef>
+              <a:spcAft>
+                <a:spcPts val="0"/>
+              </a:spcAft>
+              <a:buNone/>
+            </a:pPr>
+            <a:r>
+              <a:t/>
+            </a:r>
+            <a:endParaRPr sz="2400">
+              <a:solidFill>
+                <a:schemeClr val="lt1"/>
+              </a:solidFill>
+              <a:latin typeface="Roboto Light"/>
+              <a:ea typeface="Roboto Light"/>
+              <a:cs typeface="Roboto Light"/>
+              <a:sym typeface="Roboto Light"/>
+            </a:endParaRPr>
+          </a:p>
         </p:txBody>
       </p:sp>
       <p:sp>
         <p:nvSpPr>
-          <p:cNvPr id="195" name="Google Shape;195;p27"/>
+          <p:cNvPr id="196" name="Google Shape;196;p27"/>
           <p:cNvSpPr txBox="1"/>
           <p:nvPr/>
         </p:nvSpPr>
         <p:spPr>
           <a:xfrm>
-            <a:off x="576900" y="1011175"/>
-            <a:ext cx="7855800" cy="1227000"/>
+            <a:off x="6029475" y="947750"/>
+            <a:ext cx="2958600" cy="3598800"/>
           </a:xfrm>
           <a:prstGeom prst="rect">
             <a:avLst/>
@@ -10301,17 +10671,22 @@
           </a:bodyPr>
           <a:lstStyle/>
           <a:p>
-            <a:pPr indent="0" lvl="0" marL="0" rtl="0" algn="l">
-              <a:spcBef>
-                <a:spcPts val="0"/>
-              </a:spcBef>
-              <a:spcAft>
-                <a:spcPts val="0"/>
-              </a:spcAft>
-              <a:buNone/>
-            </a:pPr>
-            <a:r>
-              <a:rPr b="1" lang="fr" sz="1900">
+            <a:pPr indent="-342900" lvl="0" marL="457200" rtl="0" algn="l">
+              <a:spcBef>
+                <a:spcPts val="0"/>
+              </a:spcBef>
+              <a:spcAft>
+                <a:spcPts val="0"/>
+              </a:spcAft>
+              <a:buClr>
+                <a:schemeClr val="dk2"/>
+              </a:buClr>
+              <a:buSzPts val="1800"/>
+              <a:buFont typeface="Calibri"/>
+              <a:buChar char="●"/>
+            </a:pPr>
+            <a:r>
+              <a:rPr lang="fr" sz="1800">
                 <a:solidFill>
                   <a:schemeClr val="dk2"/>
                 </a:solidFill>
@@ -10320,9 +10695,9 @@
                 <a:cs typeface="Calibri"/>
                 <a:sym typeface="Calibri"/>
               </a:rPr>
-              <a:t>Par heure et par jour sur un dashboard Streamlit</a:t>
-            </a:r>
-            <a:endParaRPr b="1" sz="1900">
+              <a:t>simple</a:t>
+            </a:r>
+            <a:endParaRPr sz="1800">
               <a:solidFill>
                 <a:schemeClr val="dk2"/>
               </a:solidFill>
@@ -10333,19 +10708,57 @@
             </a:endParaRPr>
           </a:p>
           <a:p>
-            <a:pPr indent="0" lvl="0" marL="0" rtl="0" algn="l">
-              <a:spcBef>
-                <a:spcPts val="0"/>
-              </a:spcBef>
-              <a:spcAft>
-                <a:spcPts val="0"/>
-              </a:spcAft>
-              <a:buNone/>
-            </a:pPr>
-            <a:r>
-              <a:t/>
-            </a:r>
-            <a:endParaRPr b="1" sz="1900">
+            <a:pPr indent="-342900" lvl="0" marL="457200" rtl="0" algn="l">
+              <a:spcBef>
+                <a:spcPts val="0"/>
+              </a:spcBef>
+              <a:spcAft>
+                <a:spcPts val="0"/>
+              </a:spcAft>
+              <a:buClr>
+                <a:schemeClr val="dk2"/>
+              </a:buClr>
+              <a:buSzPts val="1800"/>
+              <a:buFont typeface="Calibri"/>
+              <a:buChar char="●"/>
+            </a:pPr>
+            <a:r>
+              <a:rPr lang="fr" sz="1800">
+                <a:solidFill>
+                  <a:schemeClr val="dk2"/>
+                </a:solidFill>
+                <a:latin typeface="Calibri"/>
+                <a:ea typeface="Calibri"/>
+                <a:cs typeface="Calibri"/>
+                <a:sym typeface="Calibri"/>
+              </a:rPr>
+              <a:t>pas </a:t>
+            </a:r>
+            <a:r>
+              <a:rPr lang="fr" sz="1800">
+                <a:solidFill>
+                  <a:schemeClr val="dk2"/>
+                </a:solidFill>
+                <a:latin typeface="Calibri"/>
+                <a:ea typeface="Calibri"/>
+                <a:cs typeface="Calibri"/>
+                <a:sym typeface="Calibri"/>
+              </a:rPr>
+              <a:t>d’hyperparamètres</a:t>
+            </a:r>
+            <a:r>
+              <a:rPr lang="fr" sz="1800">
+                <a:solidFill>
+                  <a:schemeClr val="dk2"/>
+                </a:solidFill>
+                <a:latin typeface="Calibri"/>
+                <a:ea typeface="Calibri"/>
+                <a:cs typeface="Calibri"/>
+                <a:sym typeface="Calibri"/>
+              </a:rPr>
+              <a:t>! (hormis la taille de l’hexagone)</a:t>
+            </a:r>
+            <a:endParaRPr sz="1800">
               <a:solidFill>
                 <a:schemeClr val="dk2"/>
               </a:solidFill>
@@ -10356,29 +10769,33 @@
             </a:endParaRPr>
           </a:p>
           <a:p>
-            <a:pPr indent="0" lvl="0" marL="0" rtl="0" algn="l">
-              <a:spcBef>
-                <a:spcPts val="0"/>
-              </a:spcBef>
-              <a:spcAft>
-                <a:spcPts val="0"/>
-              </a:spcAft>
-              <a:buNone/>
-            </a:pPr>
-            <a:r>
-              <a:rPr b="1" lang="fr" sz="1900" u="sng">
-                <a:solidFill>
-                  <a:schemeClr val="hlink"/>
+            <a:pPr indent="-342900" lvl="0" marL="457200" rtl="0" algn="l">
+              <a:spcBef>
+                <a:spcPts val="0"/>
+              </a:spcBef>
+              <a:spcAft>
+                <a:spcPts val="0"/>
+              </a:spcAft>
+              <a:buClr>
+                <a:schemeClr val="dk2"/>
+              </a:buClr>
+              <a:buSzPts val="1800"/>
+              <a:buFont typeface="Calibri"/>
+              <a:buChar char="●"/>
+            </a:pPr>
+            <a:r>
+              <a:rPr lang="fr" sz="1800">
+                <a:solidFill>
+                  <a:schemeClr val="dk2"/>
                 </a:solidFill>
                 <a:latin typeface="Calibri"/>
                 <a:ea typeface="Calibri"/>
                 <a:cs typeface="Calibri"/>
                 <a:sym typeface="Calibri"/>
-                <a:hlinkClick r:id="rId3"/>
               </a:rPr>
-              <a:t>https://jedha-project-06-uber-e5a6exs9vw6pv6o6onweus.streamlit.app/</a:t>
-            </a:r>
-            <a:endParaRPr b="1" sz="1900">
+              <a:t>calcul de la densité immédiat</a:t>
+            </a:r>
+            <a:endParaRPr sz="1800">
               <a:solidFill>
                 <a:schemeClr val="dk2"/>
               </a:solidFill>
@@ -10388,11 +10805,71 @@
               <a:sym typeface="Calibri"/>
             </a:endParaRPr>
           </a:p>
+          <a:p>
+            <a:pPr indent="-342900" lvl="0" marL="457200" rtl="0" algn="l">
+              <a:spcBef>
+                <a:spcPts val="0"/>
+              </a:spcBef>
+              <a:spcAft>
+                <a:spcPts val="0"/>
+              </a:spcAft>
+              <a:buClr>
+                <a:schemeClr val="dk2"/>
+              </a:buClr>
+              <a:buSzPts val="1800"/>
+              <a:buFont typeface="Calibri"/>
+              <a:buChar char="●"/>
+            </a:pPr>
+            <a:r>
+              <a:rPr lang="fr" sz="1800">
+                <a:solidFill>
+                  <a:schemeClr val="dk2"/>
+                </a:solidFill>
+                <a:latin typeface="Calibri"/>
+                <a:ea typeface="Calibri"/>
+                <a:cs typeface="Calibri"/>
+                <a:sym typeface="Calibri"/>
+              </a:rPr>
+              <a:t>visu plus précise des spots très denses</a:t>
+            </a:r>
+            <a:endParaRPr sz="1800">
+              <a:solidFill>
+                <a:schemeClr val="dk2"/>
+              </a:solidFill>
+              <a:latin typeface="Calibri"/>
+              <a:ea typeface="Calibri"/>
+              <a:cs typeface="Calibri"/>
+              <a:sym typeface="Calibri"/>
+            </a:endParaRPr>
+          </a:p>
+          <a:p>
+            <a:pPr indent="0" lvl="0" marL="0" rtl="0" algn="l">
+              <a:spcBef>
+                <a:spcPts val="0"/>
+              </a:spcBef>
+              <a:spcAft>
+                <a:spcPts val="0"/>
+              </a:spcAft>
+              <a:buNone/>
+            </a:pPr>
+            <a:r>
+              <a:t/>
+            </a:r>
+            <a:endParaRPr sz="1800">
+              <a:solidFill>
+                <a:schemeClr val="dk2"/>
+              </a:solidFill>
+              <a:latin typeface="Calibri"/>
+              <a:ea typeface="Calibri"/>
+              <a:cs typeface="Calibri"/>
+              <a:sym typeface="Calibri"/>
+            </a:endParaRPr>
+          </a:p>
         </p:txBody>
       </p:sp>
       <p:sp>
         <p:nvSpPr>
-          <p:cNvPr id="196" name="Google Shape;196;p27"/>
+          <p:cNvPr id="197" name="Google Shape;197;p27"/>
           <p:cNvSpPr/>
           <p:nvPr/>
         </p:nvSpPr>
@@ -10441,7 +10918,7 @@
       </p:sp>
       <p:sp>
         <p:nvSpPr>
-          <p:cNvPr id="197" name="Google Shape;197;p27"/>
+          <p:cNvPr id="198" name="Google Shape;198;p27"/>
           <p:cNvSpPr txBox="1"/>
           <p:nvPr/>
         </p:nvSpPr>
@@ -10497,6 +10974,34 @@
           </a:p>
         </p:txBody>
       </p:sp>
+      <p:pic>
+        <p:nvPicPr>
+          <p:cNvPr id="199" name="Google Shape;199;p27"/>
+          <p:cNvPicPr preferRelativeResize="0"/>
+          <p:nvPr/>
+        </p:nvPicPr>
+        <p:blipFill>
+          <a:blip r:embed="rId3">
+            <a:alphaModFix/>
+          </a:blip>
+          <a:stretch>
+            <a:fillRect/>
+          </a:stretch>
+        </p:blipFill>
+        <p:spPr>
+          <a:xfrm>
+            <a:off x="152400" y="874925"/>
+            <a:ext cx="5529140" cy="3746975"/>
+          </a:xfrm>
+          <a:prstGeom prst="rect">
+            <a:avLst/>
+          </a:prstGeom>
+          <a:noFill/>
+          <a:ln>
+            <a:noFill/>
+          </a:ln>
+        </p:spPr>
+      </p:pic>
     </p:spTree>
   </p:cSld>
   <p:clrMapOvr>
@@ -10511,13 +11016,13 @@
     <p:bg>
       <p:bgPr>
         <a:solidFill>
-          <a:srgbClr val="BF9000"/>
+          <a:schemeClr val="lt1"/>
         </a:solidFill>
       </p:bgPr>
     </p:bg>
     <p:spTree>
       <p:nvGrpSpPr>
-        <p:cNvPr id="201" name="Shape 201"/>
+        <p:cNvPr id="203" name="Shape 203"/>
         <p:cNvGrpSpPr/>
         <p:nvPr/>
       </p:nvGrpSpPr>
@@ -10531,7 +11036,1033 @@
       </p:grpSpPr>
       <p:sp>
         <p:nvSpPr>
-          <p:cNvPr id="202" name="Google Shape;202;p28"/>
+          <p:cNvPr id="204" name="Google Shape;204;p28"/>
+          <p:cNvSpPr/>
+          <p:nvPr/>
+        </p:nvSpPr>
+        <p:spPr>
+          <a:xfrm>
+            <a:off x="0" y="0"/>
+            <a:ext cx="9145200" cy="720000"/>
+          </a:xfrm>
+          <a:prstGeom prst="rect">
+            <a:avLst/>
+          </a:prstGeom>
+          <a:solidFill>
+            <a:srgbClr val="BF9000"/>
+          </a:solidFill>
+          <a:ln cap="flat" cmpd="sng" w="9525">
+            <a:solidFill>
+              <a:schemeClr val="dk2"/>
+            </a:solidFill>
+            <a:prstDash val="solid"/>
+            <a:round/>
+            <a:headEnd len="sm" w="sm" type="none"/>
+            <a:tailEnd len="sm" w="sm" type="none"/>
+          </a:ln>
+        </p:spPr>
+        <p:txBody>
+          <a:bodyPr anchorCtr="0" anchor="ctr" bIns="91425" lIns="91425" spcFirstLastPara="1" rIns="91425" wrap="square" tIns="91425">
+            <a:noAutofit/>
+          </a:bodyPr>
+          <a:lstStyle/>
+          <a:p>
+            <a:pPr indent="0" lvl="0" marL="0" rtl="0" algn="ctr">
+              <a:spcBef>
+                <a:spcPts val="0"/>
+              </a:spcBef>
+              <a:spcAft>
+                <a:spcPts val="0"/>
+              </a:spcAft>
+              <a:buNone/>
+            </a:pPr>
+            <a:r>
+              <a:t/>
+            </a:r>
+            <a:endParaRPr/>
+          </a:p>
+        </p:txBody>
+      </p:sp>
+      <p:sp>
+        <p:nvSpPr>
+          <p:cNvPr id="205" name="Google Shape;205;p28"/>
+          <p:cNvSpPr txBox="1"/>
+          <p:nvPr/>
+        </p:nvSpPr>
+        <p:spPr>
+          <a:xfrm>
+            <a:off x="365400" y="2525"/>
+            <a:ext cx="8454600" cy="720000"/>
+          </a:xfrm>
+          <a:prstGeom prst="rect">
+            <a:avLst/>
+          </a:prstGeom>
+          <a:noFill/>
+          <a:ln>
+            <a:noFill/>
+          </a:ln>
+        </p:spPr>
+        <p:txBody>
+          <a:bodyPr anchorCtr="0" anchor="t" bIns="91425" lIns="91425" spcFirstLastPara="1" rIns="91425" wrap="square" tIns="162000">
+            <a:noAutofit/>
+          </a:bodyPr>
+          <a:lstStyle/>
+          <a:p>
+            <a:pPr indent="0" lvl="0" marL="0" rtl="0" algn="l">
+              <a:spcBef>
+                <a:spcPts val="0"/>
+              </a:spcBef>
+              <a:spcAft>
+                <a:spcPts val="0"/>
+              </a:spcAft>
+              <a:buNone/>
+            </a:pPr>
+            <a:r>
+              <a:rPr lang="fr" sz="2400">
+                <a:solidFill>
+                  <a:schemeClr val="lt1"/>
+                </a:solidFill>
+                <a:latin typeface="Roboto Light"/>
+                <a:ea typeface="Roboto Light"/>
+                <a:cs typeface="Roboto Light"/>
+                <a:sym typeface="Roboto Light"/>
+              </a:rPr>
+              <a:t>Généralisation</a:t>
+            </a:r>
+            <a:endParaRPr sz="2400">
+              <a:solidFill>
+                <a:schemeClr val="lt1"/>
+              </a:solidFill>
+              <a:latin typeface="Roboto Light"/>
+              <a:ea typeface="Roboto Light"/>
+              <a:cs typeface="Roboto Light"/>
+              <a:sym typeface="Roboto Light"/>
+            </a:endParaRPr>
+          </a:p>
+        </p:txBody>
+      </p:sp>
+      <p:sp>
+        <p:nvSpPr>
+          <p:cNvPr id="206" name="Google Shape;206;p28"/>
+          <p:cNvSpPr txBox="1"/>
+          <p:nvPr/>
+        </p:nvSpPr>
+        <p:spPr>
+          <a:xfrm>
+            <a:off x="576900" y="1011175"/>
+            <a:ext cx="7855800" cy="1227000"/>
+          </a:xfrm>
+          <a:prstGeom prst="rect">
+            <a:avLst/>
+          </a:prstGeom>
+          <a:noFill/>
+          <a:ln>
+            <a:noFill/>
+          </a:ln>
+        </p:spPr>
+        <p:txBody>
+          <a:bodyPr anchorCtr="0" anchor="t" bIns="91425" lIns="91425" spcFirstLastPara="1" rIns="91425" wrap="square" tIns="91425">
+            <a:noAutofit/>
+          </a:bodyPr>
+          <a:lstStyle/>
+          <a:p>
+            <a:pPr indent="0" lvl="0" marL="0" rtl="0" algn="l">
+              <a:spcBef>
+                <a:spcPts val="0"/>
+              </a:spcBef>
+              <a:spcAft>
+                <a:spcPts val="0"/>
+              </a:spcAft>
+              <a:buNone/>
+            </a:pPr>
+            <a:r>
+              <a:rPr b="1" lang="fr" sz="1900">
+                <a:solidFill>
+                  <a:schemeClr val="dk2"/>
+                </a:solidFill>
+                <a:latin typeface="Calibri"/>
+                <a:ea typeface="Calibri"/>
+                <a:cs typeface="Calibri"/>
+                <a:sym typeface="Calibri"/>
+              </a:rPr>
+              <a:t>Par heure et par jour sur un dashboard Streamlit</a:t>
+            </a:r>
+            <a:endParaRPr b="1" sz="1900">
+              <a:solidFill>
+                <a:schemeClr val="dk2"/>
+              </a:solidFill>
+              <a:latin typeface="Calibri"/>
+              <a:ea typeface="Calibri"/>
+              <a:cs typeface="Calibri"/>
+              <a:sym typeface="Calibri"/>
+            </a:endParaRPr>
+          </a:p>
+          <a:p>
+            <a:pPr indent="0" lvl="0" marL="0" rtl="0" algn="l">
+              <a:spcBef>
+                <a:spcPts val="0"/>
+              </a:spcBef>
+              <a:spcAft>
+                <a:spcPts val="0"/>
+              </a:spcAft>
+              <a:buNone/>
+            </a:pPr>
+            <a:r>
+              <a:t/>
+            </a:r>
+            <a:endParaRPr b="1" sz="1900">
+              <a:solidFill>
+                <a:schemeClr val="dk2"/>
+              </a:solidFill>
+              <a:latin typeface="Calibri"/>
+              <a:ea typeface="Calibri"/>
+              <a:cs typeface="Calibri"/>
+              <a:sym typeface="Calibri"/>
+            </a:endParaRPr>
+          </a:p>
+          <a:p>
+            <a:pPr indent="0" lvl="0" marL="0" rtl="0" algn="l">
+              <a:spcBef>
+                <a:spcPts val="0"/>
+              </a:spcBef>
+              <a:spcAft>
+                <a:spcPts val="0"/>
+              </a:spcAft>
+              <a:buNone/>
+            </a:pPr>
+            <a:r>
+              <a:rPr b="1" lang="fr" sz="1900" u="sng">
+                <a:solidFill>
+                  <a:schemeClr val="hlink"/>
+                </a:solidFill>
+                <a:latin typeface="Calibri"/>
+                <a:ea typeface="Calibri"/>
+                <a:cs typeface="Calibri"/>
+                <a:sym typeface="Calibri"/>
+                <a:hlinkClick r:id="rId3"/>
+              </a:rPr>
+              <a:t>https://jedha-project-06-uber-e5a6exs9vw6pv6o6onweus.streamlit.app/</a:t>
+            </a:r>
+            <a:endParaRPr b="1" sz="1900">
+              <a:solidFill>
+                <a:schemeClr val="dk2"/>
+              </a:solidFill>
+              <a:latin typeface="Calibri"/>
+              <a:ea typeface="Calibri"/>
+              <a:cs typeface="Calibri"/>
+              <a:sym typeface="Calibri"/>
+            </a:endParaRPr>
+          </a:p>
+        </p:txBody>
+      </p:sp>
+      <p:sp>
+        <p:nvSpPr>
+          <p:cNvPr id="207" name="Google Shape;207;p28"/>
+          <p:cNvSpPr/>
+          <p:nvPr/>
+        </p:nvSpPr>
+        <p:spPr>
+          <a:xfrm>
+            <a:off x="-600" y="4774300"/>
+            <a:ext cx="9145200" cy="360000"/>
+          </a:xfrm>
+          <a:prstGeom prst="rect">
+            <a:avLst/>
+          </a:prstGeom>
+          <a:solidFill>
+            <a:srgbClr val="BF9000"/>
+          </a:solidFill>
+          <a:ln cap="flat" cmpd="sng" w="9525">
+            <a:solidFill>
+              <a:schemeClr val="dk2"/>
+            </a:solidFill>
+            <a:prstDash val="solid"/>
+            <a:round/>
+            <a:headEnd len="sm" w="sm" type="none"/>
+            <a:tailEnd len="sm" w="sm" type="none"/>
+          </a:ln>
+        </p:spPr>
+        <p:txBody>
+          <a:bodyPr anchorCtr="0" anchor="ctr" bIns="91425" lIns="91425" spcFirstLastPara="1" rIns="91425" wrap="square" tIns="91425">
+            <a:noAutofit/>
+          </a:bodyPr>
+          <a:lstStyle/>
+          <a:p>
+            <a:pPr indent="0" lvl="0" marL="0" rtl="0" algn="ctr">
+              <a:spcBef>
+                <a:spcPts val="0"/>
+              </a:spcBef>
+              <a:spcAft>
+                <a:spcPts val="0"/>
+              </a:spcAft>
+              <a:buNone/>
+            </a:pPr>
+            <a:r>
+              <a:t/>
+            </a:r>
+            <a:endParaRPr/>
+          </a:p>
+        </p:txBody>
+      </p:sp>
+      <p:sp>
+        <p:nvSpPr>
+          <p:cNvPr id="208" name="Google Shape;208;p28"/>
+          <p:cNvSpPr txBox="1"/>
+          <p:nvPr/>
+        </p:nvSpPr>
+        <p:spPr>
+          <a:xfrm>
+            <a:off x="365400" y="4774300"/>
+            <a:ext cx="8454600" cy="360000"/>
+          </a:xfrm>
+          <a:prstGeom prst="rect">
+            <a:avLst/>
+          </a:prstGeom>
+          <a:noFill/>
+          <a:ln>
+            <a:noFill/>
+          </a:ln>
+        </p:spPr>
+        <p:txBody>
+          <a:bodyPr anchorCtr="0" anchor="t" bIns="91425" lIns="91425" spcFirstLastPara="1" rIns="91425" wrap="square" tIns="91425">
+            <a:noAutofit/>
+          </a:bodyPr>
+          <a:lstStyle/>
+          <a:p>
+            <a:pPr indent="0" lvl="0" marL="0" rtl="0" algn="l">
+              <a:spcBef>
+                <a:spcPts val="0"/>
+              </a:spcBef>
+              <a:spcAft>
+                <a:spcPts val="0"/>
+              </a:spcAft>
+              <a:buNone/>
+            </a:pPr>
+            <a:r>
+              <a:rPr lang="fr" sz="1000">
+                <a:solidFill>
+                  <a:schemeClr val="lt1"/>
+                </a:solidFill>
+                <a:latin typeface="Calibri"/>
+                <a:ea typeface="Calibri"/>
+                <a:cs typeface="Calibri"/>
+                <a:sym typeface="Calibri"/>
+              </a:rPr>
+              <a:t>Jedha - Certification CDSD - Bloc 3 - Guillaume VIEL - 21 juillet 2026</a:t>
+            </a:r>
+            <a:endParaRPr sz="1000">
+              <a:solidFill>
+                <a:schemeClr val="lt1"/>
+              </a:solidFill>
+              <a:latin typeface="Calibri"/>
+              <a:ea typeface="Calibri"/>
+              <a:cs typeface="Calibri"/>
+              <a:sym typeface="Calibri"/>
+            </a:endParaRPr>
+          </a:p>
+        </p:txBody>
+      </p:sp>
+    </p:spTree>
+  </p:cSld>
+  <p:clrMapOvr>
+    <a:masterClrMapping/>
+  </p:clrMapOvr>
+</p:sld>
+</file>
+
+<file path=ppt/slides/slide17.xml><?xml version="1.0" encoding="utf-8"?>
+<p:sld xmlns:a="http://schemas.openxmlformats.org/drawingml/2006/main" xmlns:r="http://schemas.openxmlformats.org/officeDocument/2006/relationships" xmlns:mc="http://schemas.openxmlformats.org/markup-compatibility/2006" xmlns:mv="urn:schemas-microsoft-com:mac:vml" xmlns:p="http://schemas.openxmlformats.org/presentationml/2006/main" xmlns:c="http://schemas.openxmlformats.org/drawingml/2006/chart" xmlns:dgm="http://schemas.openxmlformats.org/drawingml/2006/diagram" xmlns:o="urn:schemas-microsoft-com:office:office" xmlns:v="urn:schemas-microsoft-com:vml" xmlns:pvml="urn:schemas-microsoft-com:office:powerpoint" xmlns:com="http://schemas.openxmlformats.org/drawingml/2006/compatibility" xmlns:p14="http://schemas.microsoft.com/office/powerpoint/2010/main" xmlns:p15="http://schemas.microsoft.com/office/powerpoint/2012/main" xmlns:ahyp="http://schemas.microsoft.com/office/drawing/2018/hyperlinkcolor">
+  <p:cSld>
+    <p:bg>
+      <p:bgPr>
+        <a:solidFill>
+          <a:srgbClr val="BF9000"/>
+        </a:solidFill>
+      </p:bgPr>
+    </p:bg>
+    <p:spTree>
+      <p:nvGrpSpPr>
+        <p:cNvPr id="212" name="Shape 212"/>
+        <p:cNvGrpSpPr/>
+        <p:nvPr/>
+      </p:nvGrpSpPr>
+      <p:grpSpPr>
+        <a:xfrm>
+          <a:off x="0" y="0"/>
+          <a:ext cx="0" cy="0"/>
+          <a:chOff x="0" y="0"/>
+          <a:chExt cx="0" cy="0"/>
+        </a:xfrm>
+      </p:grpSpPr>
+      <p:sp>
+        <p:nvSpPr>
+          <p:cNvPr id="213" name="Google Shape;213;p29"/>
+          <p:cNvSpPr/>
+          <p:nvPr/>
+        </p:nvSpPr>
+        <p:spPr>
+          <a:xfrm>
+            <a:off x="0" y="0"/>
+            <a:ext cx="9145200" cy="720000"/>
+          </a:xfrm>
+          <a:prstGeom prst="rect">
+            <a:avLst/>
+          </a:prstGeom>
+          <a:solidFill>
+            <a:srgbClr val="BF9000"/>
+          </a:solidFill>
+          <a:ln cap="flat" cmpd="sng" w="9525">
+            <a:solidFill>
+              <a:schemeClr val="dk2"/>
+            </a:solidFill>
+            <a:prstDash val="solid"/>
+            <a:round/>
+            <a:headEnd len="sm" w="sm" type="none"/>
+            <a:tailEnd len="sm" w="sm" type="none"/>
+          </a:ln>
+        </p:spPr>
+        <p:txBody>
+          <a:bodyPr anchorCtr="0" anchor="ctr" bIns="91425" lIns="91425" spcFirstLastPara="1" rIns="91425" wrap="square" tIns="91425">
+            <a:noAutofit/>
+          </a:bodyPr>
+          <a:lstStyle/>
+          <a:p>
+            <a:pPr indent="0" lvl="0" marL="0" rtl="0" algn="ctr">
+              <a:spcBef>
+                <a:spcPts val="0"/>
+              </a:spcBef>
+              <a:spcAft>
+                <a:spcPts val="0"/>
+              </a:spcAft>
+              <a:buNone/>
+            </a:pPr>
+            <a:r>
+              <a:t/>
+            </a:r>
+            <a:endParaRPr/>
+          </a:p>
+        </p:txBody>
+      </p:sp>
+      <p:sp>
+        <p:nvSpPr>
+          <p:cNvPr id="214" name="Google Shape;214;p29"/>
+          <p:cNvSpPr txBox="1"/>
+          <p:nvPr/>
+        </p:nvSpPr>
+        <p:spPr>
+          <a:xfrm>
+            <a:off x="302850" y="1990425"/>
+            <a:ext cx="8454600" cy="1422300"/>
+          </a:xfrm>
+          <a:prstGeom prst="rect">
+            <a:avLst/>
+          </a:prstGeom>
+          <a:noFill/>
+          <a:ln>
+            <a:noFill/>
+          </a:ln>
+        </p:spPr>
+        <p:txBody>
+          <a:bodyPr anchorCtr="0" anchor="t" bIns="91425" lIns="91425" spcFirstLastPara="1" rIns="91425" wrap="square" tIns="162000">
+            <a:noAutofit/>
+          </a:bodyPr>
+          <a:lstStyle/>
+          <a:p>
+            <a:pPr indent="0" lvl="0" marL="0" rtl="0" algn="ctr">
+              <a:spcBef>
+                <a:spcPts val="0"/>
+              </a:spcBef>
+              <a:spcAft>
+                <a:spcPts val="0"/>
+              </a:spcAft>
+              <a:buNone/>
+            </a:pPr>
+            <a:r>
+              <a:rPr b="1" lang="fr" sz="2400">
+                <a:solidFill>
+                  <a:schemeClr val="lt1"/>
+                </a:solidFill>
+                <a:latin typeface="Roboto"/>
+                <a:ea typeface="Roboto"/>
+                <a:cs typeface="Roboto"/>
+                <a:sym typeface="Roboto"/>
+              </a:rPr>
+              <a:t>Conclusions</a:t>
+            </a:r>
+            <a:endParaRPr b="1" sz="2400">
+              <a:solidFill>
+                <a:schemeClr val="lt1"/>
+              </a:solidFill>
+              <a:latin typeface="Roboto"/>
+              <a:ea typeface="Roboto"/>
+              <a:cs typeface="Roboto"/>
+              <a:sym typeface="Roboto"/>
+            </a:endParaRPr>
+          </a:p>
+        </p:txBody>
+      </p:sp>
+      <p:sp>
+        <p:nvSpPr>
+          <p:cNvPr id="215" name="Google Shape;215;p29"/>
+          <p:cNvSpPr/>
+          <p:nvPr/>
+        </p:nvSpPr>
+        <p:spPr>
+          <a:xfrm>
+            <a:off x="-600" y="4774300"/>
+            <a:ext cx="9145200" cy="360000"/>
+          </a:xfrm>
+          <a:prstGeom prst="rect">
+            <a:avLst/>
+          </a:prstGeom>
+          <a:solidFill>
+            <a:srgbClr val="BF9000"/>
+          </a:solidFill>
+          <a:ln cap="flat" cmpd="sng" w="9525">
+            <a:solidFill>
+              <a:schemeClr val="dk2"/>
+            </a:solidFill>
+            <a:prstDash val="solid"/>
+            <a:round/>
+            <a:headEnd len="sm" w="sm" type="none"/>
+            <a:tailEnd len="sm" w="sm" type="none"/>
+          </a:ln>
+        </p:spPr>
+        <p:txBody>
+          <a:bodyPr anchorCtr="0" anchor="ctr" bIns="91425" lIns="91425" spcFirstLastPara="1" rIns="91425" wrap="square" tIns="91425">
+            <a:noAutofit/>
+          </a:bodyPr>
+          <a:lstStyle/>
+          <a:p>
+            <a:pPr indent="0" lvl="0" marL="0" rtl="0" algn="ctr">
+              <a:spcBef>
+                <a:spcPts val="0"/>
+              </a:spcBef>
+              <a:spcAft>
+                <a:spcPts val="0"/>
+              </a:spcAft>
+              <a:buNone/>
+            </a:pPr>
+            <a:r>
+              <a:t/>
+            </a:r>
+            <a:endParaRPr/>
+          </a:p>
+        </p:txBody>
+      </p:sp>
+      <p:sp>
+        <p:nvSpPr>
+          <p:cNvPr id="216" name="Google Shape;216;p29"/>
+          <p:cNvSpPr txBox="1"/>
+          <p:nvPr/>
+        </p:nvSpPr>
+        <p:spPr>
+          <a:xfrm>
+            <a:off x="365400" y="4774300"/>
+            <a:ext cx="8454600" cy="360000"/>
+          </a:xfrm>
+          <a:prstGeom prst="rect">
+            <a:avLst/>
+          </a:prstGeom>
+          <a:noFill/>
+          <a:ln>
+            <a:noFill/>
+          </a:ln>
+        </p:spPr>
+        <p:txBody>
+          <a:bodyPr anchorCtr="0" anchor="t" bIns="91425" lIns="91425" spcFirstLastPara="1" rIns="91425" wrap="square" tIns="91425">
+            <a:noAutofit/>
+          </a:bodyPr>
+          <a:lstStyle/>
+          <a:p>
+            <a:pPr indent="0" lvl="0" marL="0" rtl="0" algn="l">
+              <a:spcBef>
+                <a:spcPts val="0"/>
+              </a:spcBef>
+              <a:spcAft>
+                <a:spcPts val="0"/>
+              </a:spcAft>
+              <a:buNone/>
+            </a:pPr>
+            <a:r>
+              <a:rPr lang="fr" sz="1000">
+                <a:solidFill>
+                  <a:schemeClr val="lt1"/>
+                </a:solidFill>
+                <a:latin typeface="Calibri"/>
+                <a:ea typeface="Calibri"/>
+                <a:cs typeface="Calibri"/>
+                <a:sym typeface="Calibri"/>
+              </a:rPr>
+              <a:t>Jedha - Certification CDSD - Bloc 3 - Guillaume VIEL - 21 juillet 2026</a:t>
+            </a:r>
+            <a:endParaRPr sz="1000">
+              <a:solidFill>
+                <a:schemeClr val="lt1"/>
+              </a:solidFill>
+              <a:latin typeface="Calibri"/>
+              <a:ea typeface="Calibri"/>
+              <a:cs typeface="Calibri"/>
+              <a:sym typeface="Calibri"/>
+            </a:endParaRPr>
+          </a:p>
+        </p:txBody>
+      </p:sp>
+    </p:spTree>
+  </p:cSld>
+  <p:clrMapOvr>
+    <a:masterClrMapping/>
+  </p:clrMapOvr>
+</p:sld>
+</file>
+
+<file path=ppt/slides/slide18.xml><?xml version="1.0" encoding="utf-8"?>
+<p:sld xmlns:a="http://schemas.openxmlformats.org/drawingml/2006/main" xmlns:r="http://schemas.openxmlformats.org/officeDocument/2006/relationships" xmlns:mc="http://schemas.openxmlformats.org/markup-compatibility/2006" xmlns:mv="urn:schemas-microsoft-com:mac:vml" xmlns:p="http://schemas.openxmlformats.org/presentationml/2006/main" xmlns:c="http://schemas.openxmlformats.org/drawingml/2006/chart" xmlns:dgm="http://schemas.openxmlformats.org/drawingml/2006/diagram" xmlns:o="urn:schemas-microsoft-com:office:office" xmlns:v="urn:schemas-microsoft-com:vml" xmlns:pvml="urn:schemas-microsoft-com:office:powerpoint" xmlns:com="http://schemas.openxmlformats.org/drawingml/2006/compatibility" xmlns:p14="http://schemas.microsoft.com/office/powerpoint/2010/main" xmlns:p15="http://schemas.microsoft.com/office/powerpoint/2012/main" xmlns:ahyp="http://schemas.microsoft.com/office/drawing/2018/hyperlinkcolor">
+  <p:cSld>
+    <p:bg>
+      <p:bgPr>
+        <a:solidFill>
+          <a:schemeClr val="lt1"/>
+        </a:solidFill>
+      </p:bgPr>
+    </p:bg>
+    <p:spTree>
+      <p:nvGrpSpPr>
+        <p:cNvPr id="220" name="Shape 220"/>
+        <p:cNvGrpSpPr/>
+        <p:nvPr/>
+      </p:nvGrpSpPr>
+      <p:grpSpPr>
+        <a:xfrm>
+          <a:off x="0" y="0"/>
+          <a:ext cx="0" cy="0"/>
+          <a:chOff x="0" y="0"/>
+          <a:chExt cx="0" cy="0"/>
+        </a:xfrm>
+      </p:grpSpPr>
+      <p:sp>
+        <p:nvSpPr>
+          <p:cNvPr id="221" name="Google Shape;221;p30"/>
+          <p:cNvSpPr/>
+          <p:nvPr/>
+        </p:nvSpPr>
+        <p:spPr>
+          <a:xfrm>
+            <a:off x="0" y="0"/>
+            <a:ext cx="9145200" cy="720000"/>
+          </a:xfrm>
+          <a:prstGeom prst="rect">
+            <a:avLst/>
+          </a:prstGeom>
+          <a:solidFill>
+            <a:srgbClr val="BF9000"/>
+          </a:solidFill>
+          <a:ln cap="flat" cmpd="sng" w="9525">
+            <a:solidFill>
+              <a:schemeClr val="dk2"/>
+            </a:solidFill>
+            <a:prstDash val="solid"/>
+            <a:round/>
+            <a:headEnd len="sm" w="sm" type="none"/>
+            <a:tailEnd len="sm" w="sm" type="none"/>
+          </a:ln>
+        </p:spPr>
+        <p:txBody>
+          <a:bodyPr anchorCtr="0" anchor="ctr" bIns="91425" lIns="91425" spcFirstLastPara="1" rIns="91425" wrap="square" tIns="91425">
+            <a:noAutofit/>
+          </a:bodyPr>
+          <a:lstStyle/>
+          <a:p>
+            <a:pPr indent="0" lvl="0" marL="0" rtl="0" algn="ctr">
+              <a:spcBef>
+                <a:spcPts val="0"/>
+              </a:spcBef>
+              <a:spcAft>
+                <a:spcPts val="0"/>
+              </a:spcAft>
+              <a:buNone/>
+            </a:pPr>
+            <a:r>
+              <a:t/>
+            </a:r>
+            <a:endParaRPr/>
+          </a:p>
+        </p:txBody>
+      </p:sp>
+      <p:sp>
+        <p:nvSpPr>
+          <p:cNvPr id="222" name="Google Shape;222;p30"/>
+          <p:cNvSpPr txBox="1"/>
+          <p:nvPr/>
+        </p:nvSpPr>
+        <p:spPr>
+          <a:xfrm>
+            <a:off x="365400" y="2525"/>
+            <a:ext cx="8454600" cy="720000"/>
+          </a:xfrm>
+          <a:prstGeom prst="rect">
+            <a:avLst/>
+          </a:prstGeom>
+          <a:noFill/>
+          <a:ln>
+            <a:noFill/>
+          </a:ln>
+        </p:spPr>
+        <p:txBody>
+          <a:bodyPr anchorCtr="0" anchor="t" bIns="91425" lIns="91425" spcFirstLastPara="1" rIns="91425" wrap="square" tIns="162000">
+            <a:noAutofit/>
+          </a:bodyPr>
+          <a:lstStyle/>
+          <a:p>
+            <a:pPr indent="0" lvl="0" marL="0" rtl="0" algn="l">
+              <a:spcBef>
+                <a:spcPts val="0"/>
+              </a:spcBef>
+              <a:spcAft>
+                <a:spcPts val="0"/>
+              </a:spcAft>
+              <a:buNone/>
+            </a:pPr>
+            <a:r>
+              <a:rPr lang="fr" sz="2400">
+                <a:solidFill>
+                  <a:schemeClr val="lt1"/>
+                </a:solidFill>
+                <a:latin typeface="Roboto Light"/>
+                <a:ea typeface="Roboto Light"/>
+                <a:cs typeface="Roboto Light"/>
+                <a:sym typeface="Roboto Light"/>
+              </a:rPr>
+              <a:t>Conclusions</a:t>
+            </a:r>
+            <a:endParaRPr sz="2400">
+              <a:solidFill>
+                <a:schemeClr val="lt1"/>
+              </a:solidFill>
+              <a:latin typeface="Roboto Light"/>
+              <a:ea typeface="Roboto Light"/>
+              <a:cs typeface="Roboto Light"/>
+              <a:sym typeface="Roboto Light"/>
+            </a:endParaRPr>
+          </a:p>
+        </p:txBody>
+      </p:sp>
+      <p:sp>
+        <p:nvSpPr>
+          <p:cNvPr id="223" name="Google Shape;223;p30"/>
+          <p:cNvSpPr txBox="1"/>
+          <p:nvPr/>
+        </p:nvSpPr>
+        <p:spPr>
+          <a:xfrm>
+            <a:off x="576900" y="1011175"/>
+            <a:ext cx="7855800" cy="1227000"/>
+          </a:xfrm>
+          <a:prstGeom prst="rect">
+            <a:avLst/>
+          </a:prstGeom>
+          <a:noFill/>
+          <a:ln>
+            <a:noFill/>
+          </a:ln>
+        </p:spPr>
+        <p:txBody>
+          <a:bodyPr anchorCtr="0" anchor="t" bIns="91425" lIns="91425" spcFirstLastPara="1" rIns="91425" wrap="square" tIns="91425">
+            <a:noAutofit/>
+          </a:bodyPr>
+          <a:lstStyle/>
+          <a:p>
+            <a:pPr indent="-349250" lvl="0" marL="457200" rtl="0" algn="l">
+              <a:spcBef>
+                <a:spcPts val="0"/>
+              </a:spcBef>
+              <a:spcAft>
+                <a:spcPts val="0"/>
+              </a:spcAft>
+              <a:buClr>
+                <a:schemeClr val="dk2"/>
+              </a:buClr>
+              <a:buSzPts val="1900"/>
+              <a:buFont typeface="Calibri"/>
+              <a:buChar char="●"/>
+            </a:pPr>
+            <a:r>
+              <a:rPr b="1" lang="fr" sz="1900">
+                <a:solidFill>
+                  <a:schemeClr val="dk2"/>
+                </a:solidFill>
+                <a:latin typeface="Calibri"/>
+                <a:ea typeface="Calibri"/>
+                <a:cs typeface="Calibri"/>
+                <a:sym typeface="Calibri"/>
+              </a:rPr>
+              <a:t>K-Means pas très adapté dans ce cas</a:t>
+            </a:r>
+            <a:endParaRPr b="1" sz="1900">
+              <a:solidFill>
+                <a:schemeClr val="dk2"/>
+              </a:solidFill>
+              <a:latin typeface="Calibri"/>
+              <a:ea typeface="Calibri"/>
+              <a:cs typeface="Calibri"/>
+              <a:sym typeface="Calibri"/>
+            </a:endParaRPr>
+          </a:p>
+          <a:p>
+            <a:pPr indent="-349250" lvl="0" marL="457200" rtl="0" algn="l">
+              <a:spcBef>
+                <a:spcPts val="0"/>
+              </a:spcBef>
+              <a:spcAft>
+                <a:spcPts val="0"/>
+              </a:spcAft>
+              <a:buClr>
+                <a:schemeClr val="dk2"/>
+              </a:buClr>
+              <a:buSzPts val="1900"/>
+              <a:buFont typeface="Calibri"/>
+              <a:buChar char="●"/>
+            </a:pPr>
+            <a:r>
+              <a:rPr b="1" lang="fr" sz="1900">
+                <a:solidFill>
+                  <a:schemeClr val="dk2"/>
+                </a:solidFill>
+                <a:latin typeface="Calibri"/>
+                <a:ea typeface="Calibri"/>
+                <a:cs typeface="Calibri"/>
+                <a:sym typeface="Calibri"/>
+              </a:rPr>
+              <a:t>Modèle H3</a:t>
+            </a:r>
+            <a:endParaRPr b="1" sz="1900">
+              <a:solidFill>
+                <a:schemeClr val="dk2"/>
+              </a:solidFill>
+              <a:latin typeface="Calibri"/>
+              <a:ea typeface="Calibri"/>
+              <a:cs typeface="Calibri"/>
+              <a:sym typeface="Calibri"/>
+            </a:endParaRPr>
+          </a:p>
+          <a:p>
+            <a:pPr indent="-349250" lvl="1" marL="914400" rtl="0" algn="l">
+              <a:spcBef>
+                <a:spcPts val="0"/>
+              </a:spcBef>
+              <a:spcAft>
+                <a:spcPts val="0"/>
+              </a:spcAft>
+              <a:buClr>
+                <a:schemeClr val="dk2"/>
+              </a:buClr>
+              <a:buSzPts val="1900"/>
+              <a:buFont typeface="Calibri"/>
+              <a:buChar char="○"/>
+            </a:pPr>
+            <a:r>
+              <a:rPr b="1" lang="fr" sz="1900">
+                <a:solidFill>
+                  <a:schemeClr val="dk2"/>
+                </a:solidFill>
+                <a:latin typeface="Calibri"/>
+                <a:ea typeface="Calibri"/>
+                <a:cs typeface="Calibri"/>
+                <a:sym typeface="Calibri"/>
+              </a:rPr>
+              <a:t>plus simple à mettre en oeuvre</a:t>
+            </a:r>
+            <a:endParaRPr b="1" sz="1900">
+              <a:solidFill>
+                <a:schemeClr val="dk2"/>
+              </a:solidFill>
+              <a:latin typeface="Calibri"/>
+              <a:ea typeface="Calibri"/>
+              <a:cs typeface="Calibri"/>
+              <a:sym typeface="Calibri"/>
+            </a:endParaRPr>
+          </a:p>
+          <a:p>
+            <a:pPr indent="-349250" lvl="1" marL="914400" rtl="0" algn="l">
+              <a:spcBef>
+                <a:spcPts val="0"/>
+              </a:spcBef>
+              <a:spcAft>
+                <a:spcPts val="0"/>
+              </a:spcAft>
+              <a:buClr>
+                <a:schemeClr val="dk2"/>
+              </a:buClr>
+              <a:buSzPts val="1900"/>
+              <a:buFont typeface="Calibri"/>
+              <a:buChar char="○"/>
+            </a:pPr>
+            <a:r>
+              <a:rPr b="1" lang="fr" sz="1900">
+                <a:solidFill>
+                  <a:schemeClr val="dk2"/>
+                </a:solidFill>
+                <a:latin typeface="Calibri"/>
+                <a:ea typeface="Calibri"/>
+                <a:cs typeface="Calibri"/>
+                <a:sym typeface="Calibri"/>
+              </a:rPr>
+              <a:t>plus efficace en terme de visualisation</a:t>
+            </a:r>
+            <a:endParaRPr b="1" sz="1900">
+              <a:solidFill>
+                <a:schemeClr val="dk2"/>
+              </a:solidFill>
+              <a:latin typeface="Calibri"/>
+              <a:ea typeface="Calibri"/>
+              <a:cs typeface="Calibri"/>
+              <a:sym typeface="Calibri"/>
+            </a:endParaRPr>
+          </a:p>
+        </p:txBody>
+      </p:sp>
+      <p:sp>
+        <p:nvSpPr>
+          <p:cNvPr id="224" name="Google Shape;224;p30"/>
+          <p:cNvSpPr/>
+          <p:nvPr/>
+        </p:nvSpPr>
+        <p:spPr>
+          <a:xfrm>
+            <a:off x="-600" y="4774300"/>
+            <a:ext cx="9145200" cy="360000"/>
+          </a:xfrm>
+          <a:prstGeom prst="rect">
+            <a:avLst/>
+          </a:prstGeom>
+          <a:solidFill>
+            <a:srgbClr val="BF9000"/>
+          </a:solidFill>
+          <a:ln cap="flat" cmpd="sng" w="9525">
+            <a:solidFill>
+              <a:schemeClr val="dk2"/>
+            </a:solidFill>
+            <a:prstDash val="solid"/>
+            <a:round/>
+            <a:headEnd len="sm" w="sm" type="none"/>
+            <a:tailEnd len="sm" w="sm" type="none"/>
+          </a:ln>
+        </p:spPr>
+        <p:txBody>
+          <a:bodyPr anchorCtr="0" anchor="ctr" bIns="91425" lIns="91425" spcFirstLastPara="1" rIns="91425" wrap="square" tIns="91425">
+            <a:noAutofit/>
+          </a:bodyPr>
+          <a:lstStyle/>
+          <a:p>
+            <a:pPr indent="0" lvl="0" marL="0" rtl="0" algn="ctr">
+              <a:spcBef>
+                <a:spcPts val="0"/>
+              </a:spcBef>
+              <a:spcAft>
+                <a:spcPts val="0"/>
+              </a:spcAft>
+              <a:buNone/>
+            </a:pPr>
+            <a:r>
+              <a:t/>
+            </a:r>
+            <a:endParaRPr/>
+          </a:p>
+        </p:txBody>
+      </p:sp>
+      <p:sp>
+        <p:nvSpPr>
+          <p:cNvPr id="225" name="Google Shape;225;p30"/>
+          <p:cNvSpPr txBox="1"/>
+          <p:nvPr/>
+        </p:nvSpPr>
+        <p:spPr>
+          <a:xfrm>
+            <a:off x="365400" y="4774300"/>
+            <a:ext cx="8454600" cy="360000"/>
+          </a:xfrm>
+          <a:prstGeom prst="rect">
+            <a:avLst/>
+          </a:prstGeom>
+          <a:noFill/>
+          <a:ln>
+            <a:noFill/>
+          </a:ln>
+        </p:spPr>
+        <p:txBody>
+          <a:bodyPr anchorCtr="0" anchor="t" bIns="91425" lIns="91425" spcFirstLastPara="1" rIns="91425" wrap="square" tIns="91425">
+            <a:noAutofit/>
+          </a:bodyPr>
+          <a:lstStyle/>
+          <a:p>
+            <a:pPr indent="0" lvl="0" marL="0" rtl="0" algn="l">
+              <a:spcBef>
+                <a:spcPts val="0"/>
+              </a:spcBef>
+              <a:spcAft>
+                <a:spcPts val="0"/>
+              </a:spcAft>
+              <a:buNone/>
+            </a:pPr>
+            <a:r>
+              <a:rPr lang="fr" sz="1000">
+                <a:solidFill>
+                  <a:schemeClr val="lt1"/>
+                </a:solidFill>
+                <a:latin typeface="Calibri"/>
+                <a:ea typeface="Calibri"/>
+                <a:cs typeface="Calibri"/>
+                <a:sym typeface="Calibri"/>
+              </a:rPr>
+              <a:t>Jedha - Certification CDSD - Bloc 3 - Guillaume VIEL - 21 juillet 2026</a:t>
+            </a:r>
+            <a:endParaRPr sz="1000">
+              <a:solidFill>
+                <a:schemeClr val="lt1"/>
+              </a:solidFill>
+              <a:latin typeface="Calibri"/>
+              <a:ea typeface="Calibri"/>
+              <a:cs typeface="Calibri"/>
+              <a:sym typeface="Calibri"/>
+            </a:endParaRPr>
+          </a:p>
+        </p:txBody>
+      </p:sp>
+    </p:spTree>
+  </p:cSld>
+  <p:clrMapOvr>
+    <a:masterClrMapping/>
+  </p:clrMapOvr>
+</p:sld>
+</file>
+
+<file path=ppt/slides/slide19.xml><?xml version="1.0" encoding="utf-8"?>
+<p:sld xmlns:a="http://schemas.openxmlformats.org/drawingml/2006/main" xmlns:r="http://schemas.openxmlformats.org/officeDocument/2006/relationships" xmlns:mc="http://schemas.openxmlformats.org/markup-compatibility/2006" xmlns:mv="urn:schemas-microsoft-com:mac:vml" xmlns:p="http://schemas.openxmlformats.org/presentationml/2006/main" xmlns:c="http://schemas.openxmlformats.org/drawingml/2006/chart" xmlns:dgm="http://schemas.openxmlformats.org/drawingml/2006/diagram" xmlns:o="urn:schemas-microsoft-com:office:office" xmlns:v="urn:schemas-microsoft-com:vml" xmlns:pvml="urn:schemas-microsoft-com:office:powerpoint" xmlns:com="http://schemas.openxmlformats.org/drawingml/2006/compatibility" xmlns:p14="http://schemas.microsoft.com/office/powerpoint/2010/main" xmlns:p15="http://schemas.microsoft.com/office/powerpoint/2012/main" xmlns:ahyp="http://schemas.microsoft.com/office/drawing/2018/hyperlinkcolor">
+  <p:cSld>
+    <p:bg>
+      <p:bgPr>
+        <a:solidFill>
+          <a:srgbClr val="BF9000"/>
+        </a:solidFill>
+      </p:bgPr>
+    </p:bg>
+    <p:spTree>
+      <p:nvGrpSpPr>
+        <p:cNvPr id="229" name="Shape 229"/>
+        <p:cNvGrpSpPr/>
+        <p:nvPr/>
+      </p:nvGrpSpPr>
+      <p:grpSpPr>
+        <a:xfrm>
+          <a:off x="0" y="0"/>
+          <a:ext cx="0" cy="0"/>
+          <a:chOff x="0" y="0"/>
+          <a:chExt cx="0" cy="0"/>
+        </a:xfrm>
+      </p:grpSpPr>
+      <p:sp>
+        <p:nvSpPr>
+          <p:cNvPr id="230" name="Google Shape;230;p31"/>
           <p:cNvSpPr txBox="1"/>
           <p:nvPr/>
         </p:nvSpPr>
@@ -10589,7 +12120,7 @@
       </p:sp>
       <p:sp>
         <p:nvSpPr>
-          <p:cNvPr id="203" name="Google Shape;203;p28"/>
+          <p:cNvPr id="231" name="Google Shape;231;p31"/>
           <p:cNvSpPr txBox="1"/>
           <p:nvPr/>
         </p:nvSpPr>
@@ -10666,7 +12197,7 @@
       </p:sp>
       <p:sp>
         <p:nvSpPr>
-          <p:cNvPr id="204" name="Google Shape;204;p28"/>
+          <p:cNvPr id="232" name="Google Shape;232;p31"/>
           <p:cNvSpPr txBox="1"/>
           <p:nvPr/>
         </p:nvSpPr>
@@ -10724,7 +12255,7 @@
       </p:sp>
       <p:pic>
         <p:nvPicPr>
-          <p:cNvPr id="205" name="Google Shape;205;p28"/>
+          <p:cNvPr id="233" name="Google Shape;233;p31"/>
           <p:cNvPicPr preferRelativeResize="0"/>
           <p:nvPr/>
         </p:nvPicPr>
@@ -10751,7 +12282,7 @@
       </p:pic>
       <p:cxnSp>
         <p:nvCxnSpPr>
-          <p:cNvPr id="206" name="Google Shape;206;p28"/>
+          <p:cNvPr id="234" name="Google Shape;234;p31"/>
           <p:cNvCxnSpPr/>
           <p:nvPr/>
         </p:nvCxnSpPr>
@@ -10777,7 +12308,7 @@
       </p:cxnSp>
       <p:sp>
         <p:nvSpPr>
-          <p:cNvPr id="207" name="Google Shape;207;p28"/>
+          <p:cNvPr id="235" name="Google Shape;235;p31"/>
           <p:cNvSpPr txBox="1"/>
           <p:nvPr/>
         </p:nvSpPr>

</xml_diff>